<commit_message>
BP v29: pare the personal-agent page down to three lines of story
Page 10 is now four numbers (Muse, Dots, Instinct $10B, 16.1% on the
Remote Labor Index), the practice loop as one line, and the kicker. The
data rules move to the business-model note box.

Co-Authored-By: Claude Opus 5.5 <noreply@anthropic.com>
Claude-Session: https://claude.ai/code/session_01EKqGwTA92C8Wo4e47t73NN
</commit_message>
<xml_diff>
--- a/SimReal-BP-v29-EN.pptx
+++ b/SimReal-BP-v29-EN.pptx
@@ -10290,7 +10290,7 @@
         <p:spPr>
           <a:xfrm>
             <a:off x="548640" y="4882896"/>
-            <a:ext cx="3544824" cy="1024128"/>
+            <a:ext cx="3544824" cy="1152144"/>
           </a:xfrm>
           <a:prstGeom prst="rect">
             <a:avLst/>
@@ -10440,7 +10440,7 @@
         <p:spPr>
           <a:xfrm>
             <a:off x="4322064" y="4882896"/>
-            <a:ext cx="3544824" cy="1024128"/>
+            <a:ext cx="3544824" cy="1152144"/>
           </a:xfrm>
           <a:prstGeom prst="rect">
             <a:avLst/>
@@ -10590,7 +10590,7 @@
         <p:spPr>
           <a:xfrm>
             <a:off x="8095488" y="4882896"/>
-            <a:ext cx="3544824" cy="1024128"/>
+            <a:ext cx="3544824" cy="1152144"/>
           </a:xfrm>
           <a:prstGeom prst="rect">
             <a:avLst/>
@@ -10726,7 +10726,30 @@
                 <a:cs typeface="Instrument Sans"/>
                 <a:sym typeface="Instrument Sans"/>
               </a:rPr>
-              <a:t>Agent developers pay to practice; private by default</a:t>
+              <a:t>Agents pay to practice, private by default,</a:t>
+            </a:r>
+          </a:p>
+          <a:p>
+            <a:pPr marL="0" marR="0" lvl="0" indent="0" algn="l" rtl="0">
+              <a:spcBef>
+                <a:spcPts val="200"/>
+              </a:spcBef>
+              <a:spcAft>
+                <a:spcPts val="0"/>
+              </a:spcAft>
+              <a:buNone/>
+            </a:pPr>
+            <a:r>
+              <a:rPr lang="en-US" sz="1000" b="0" i="0" u="none" strike="noStrike" cap="none">
+                <a:solidFill>
+                  <a:srgbClr val="33322F"/>
+                </a:solidFill>
+                <a:latin typeface="Instrument Sans"/>
+                <a:ea typeface="Instrument Sans"/>
+                <a:cs typeface="Instrument Sans"/>
+                <a:sym typeface="Instrument Sans"/>
+              </a:rPr>
+              <a:t>or share de-identified runs for credits and a cut</a:t>
             </a:r>
           </a:p>
         </p:txBody>
@@ -30366,7 +30389,7 @@
                 <a:cs typeface="Newsreader"/>
                 <a:sym typeface="Newsreader"/>
               </a:rPr>
-              <a:t>Next · Personal agents</a:t>
+              <a:t>Personal agents</a:t>
             </a:r>
           </a:p>
         </p:txBody>
@@ -30476,7 +30499,7 @@
                 <a:cs typeface="IBM Plex Mono"/>
                 <a:sym typeface="IBM Plex Mono"/>
               </a:rPr>
-              <a:t>September 2026: the personal-agent race is on</a:t>
+              <a:t>Personal agents are here</a:t>
             </a:r>
           </a:p>
         </p:txBody>
@@ -30518,8 +30541,8 @@
         </p:nvSpPr>
         <p:spPr>
           <a:xfrm>
-            <a:off x="548640" y="1865376"/>
-            <a:ext cx="2567178" cy="201168"/>
+            <a:off x="548640" y="1883664"/>
+            <a:ext cx="2567178" cy="658368"/>
           </a:xfrm>
           <a:prstGeom prst="rect">
             <a:avLst/>
@@ -30545,7 +30568,524 @@
               <a:buNone/>
             </a:pPr>
             <a:r>
-              <a:rPr lang="en-US" sz="950" b="0" i="0" u="none" strike="noStrike" cap="none">
+              <a:rPr lang="en-US" sz="4000" b="0" i="0" u="none" strike="noStrike" cap="none">
+                <a:solidFill>
+                  <a:srgbClr val="111110"/>
+                </a:solidFill>
+                <a:latin typeface="Newsreader"/>
+                <a:ea typeface="Newsreader"/>
+                <a:cs typeface="Newsreader"/>
+                <a:sym typeface="Newsreader"/>
+              </a:rPr>
+              <a:t>Muse</a:t>
+            </a:r>
+          </a:p>
+        </p:txBody>
+      </p:sp>
+      <p:sp>
+        <p:nvSpPr>
+          <p:cNvPr id="5008" name="SimReal 5008"/>
+          <p:cNvSpPr txBox="1"/>
+          <p:nvPr/>
+        </p:nvSpPr>
+        <p:spPr>
+          <a:xfrm>
+            <a:off x="548640" y="2596896"/>
+            <a:ext cx="2567178" cy="457200"/>
+          </a:xfrm>
+          <a:prstGeom prst="rect">
+            <a:avLst/>
+          </a:prstGeom>
+          <a:noFill/>
+          <a:ln>
+            <a:noFill/>
+          </a:ln>
+        </p:spPr>
+        <p:txBody>
+          <a:bodyPr spcFirstLastPara="1" wrap="square" lIns="0" tIns="0" rIns="0" bIns="0" anchor="t" anchorCtr="0">
+            <a:noAutofit/>
+          </a:bodyPr>
+          <a:lstStyle/>
+          <a:p>
+            <a:pPr marL="0" marR="0" lvl="0" indent="0" algn="l" rtl="0">
+              <a:lnSpc>
+                <a:spcPct val="110000"/>
+              </a:lnSpc>
+              <a:spcBef>
+                <a:spcPts val="0"/>
+              </a:spcBef>
+              <a:spcAft>
+                <a:spcPts val="0"/>
+              </a:spcAft>
+              <a:buNone/>
+            </a:pPr>
+            <a:r>
+              <a:rPr lang="en-US" sz="1150" b="0" i="0" u="none" strike="noStrike" cap="none">
+                <a:solidFill>
+                  <a:srgbClr val="33322F"/>
+                </a:solidFill>
+                <a:latin typeface="Instrument Sans"/>
+                <a:ea typeface="Instrument Sans"/>
+                <a:cs typeface="Instrument Sans"/>
+                <a:sym typeface="Instrument Sans"/>
+              </a:rPr>
+              <a:t>Meta, launched Sep 8</a:t>
+            </a:r>
+          </a:p>
+        </p:txBody>
+      </p:sp>
+      <p:sp>
+        <p:nvSpPr>
+          <p:cNvPr id="5009" name="SimReal 5009"/>
+          <p:cNvSpPr/>
+          <p:nvPr/>
+        </p:nvSpPr>
+        <p:spPr>
+          <a:xfrm>
+            <a:off x="3390138" y="1755648"/>
+            <a:ext cx="2567178" cy="18288"/>
+          </a:xfrm>
+          <a:prstGeom prst="rect">
+            <a:avLst/>
+          </a:prstGeom>
+          <a:solidFill>
+            <a:srgbClr val="111110"/>
+          </a:solidFill>
+          <a:ln>
+            <a:noFill/>
+          </a:ln>
+        </p:spPr>
+        <p:txBody>
+          <a:bodyPr/>
+          <a:lstStyle/>
+          <a:p>
+            <a:endParaRPr/>
+          </a:p>
+        </p:txBody>
+      </p:sp>
+      <p:sp>
+        <p:nvSpPr>
+          <p:cNvPr id="5010" name="SimReal 5010"/>
+          <p:cNvSpPr txBox="1"/>
+          <p:nvPr/>
+        </p:nvSpPr>
+        <p:spPr>
+          <a:xfrm>
+            <a:off x="3390138" y="1883664"/>
+            <a:ext cx="2567178" cy="658368"/>
+          </a:xfrm>
+          <a:prstGeom prst="rect">
+            <a:avLst/>
+          </a:prstGeom>
+          <a:noFill/>
+          <a:ln>
+            <a:noFill/>
+          </a:ln>
+        </p:spPr>
+        <p:txBody>
+          <a:bodyPr spcFirstLastPara="1" wrap="square" lIns="0" tIns="0" rIns="0" bIns="0" anchor="t" anchorCtr="0">
+            <a:noAutofit/>
+          </a:bodyPr>
+          <a:lstStyle/>
+          <a:p>
+            <a:pPr marL="0" marR="0" lvl="0" indent="0" algn="l" rtl="0">
+              <a:spcBef>
+                <a:spcPts val="0"/>
+              </a:spcBef>
+              <a:spcAft>
+                <a:spcPts val="0"/>
+              </a:spcAft>
+              <a:buNone/>
+            </a:pPr>
+            <a:r>
+              <a:rPr lang="en-US" sz="4000" b="0" i="0" u="none" strike="noStrike" cap="none">
+                <a:solidFill>
+                  <a:srgbClr val="111110"/>
+                </a:solidFill>
+                <a:latin typeface="Newsreader"/>
+                <a:ea typeface="Newsreader"/>
+                <a:cs typeface="Newsreader"/>
+                <a:sym typeface="Newsreader"/>
+              </a:rPr>
+              <a:t>Dots</a:t>
+            </a:r>
+          </a:p>
+        </p:txBody>
+      </p:sp>
+      <p:sp>
+        <p:nvSpPr>
+          <p:cNvPr id="5011" name="SimReal 5011"/>
+          <p:cNvSpPr txBox="1"/>
+          <p:nvPr/>
+        </p:nvSpPr>
+        <p:spPr>
+          <a:xfrm>
+            <a:off x="3390138" y="2596896"/>
+            <a:ext cx="2567178" cy="457200"/>
+          </a:xfrm>
+          <a:prstGeom prst="rect">
+            <a:avLst/>
+          </a:prstGeom>
+          <a:noFill/>
+          <a:ln>
+            <a:noFill/>
+          </a:ln>
+        </p:spPr>
+        <p:txBody>
+          <a:bodyPr spcFirstLastPara="1" wrap="square" lIns="0" tIns="0" rIns="0" bIns="0" anchor="t" anchorCtr="0">
+            <a:noAutofit/>
+          </a:bodyPr>
+          <a:lstStyle/>
+          <a:p>
+            <a:pPr marL="0" marR="0" lvl="0" indent="0" algn="l" rtl="0">
+              <a:lnSpc>
+                <a:spcPct val="110000"/>
+              </a:lnSpc>
+              <a:spcBef>
+                <a:spcPts val="0"/>
+              </a:spcBef>
+              <a:spcAft>
+                <a:spcPts val="0"/>
+              </a:spcAft>
+              <a:buNone/>
+            </a:pPr>
+            <a:r>
+              <a:rPr lang="en-US" sz="1150" b="0" i="0" u="none" strike="noStrike" cap="none">
+                <a:solidFill>
+                  <a:srgbClr val="33322F"/>
+                </a:solidFill>
+                <a:latin typeface="Instrument Sans"/>
+                <a:ea typeface="Instrument Sans"/>
+                <a:cs typeface="Instrument Sans"/>
+                <a:sym typeface="Instrument Sans"/>
+              </a:rPr>
+              <a:t>OpenAI, unveiled Sep 29</a:t>
+            </a:r>
+          </a:p>
+        </p:txBody>
+      </p:sp>
+      <p:sp>
+        <p:nvSpPr>
+          <p:cNvPr id="5012" name="SimReal 5012"/>
+          <p:cNvSpPr/>
+          <p:nvPr/>
+        </p:nvSpPr>
+        <p:spPr>
+          <a:xfrm>
+            <a:off x="6231636" y="1755648"/>
+            <a:ext cx="2567178" cy="18288"/>
+          </a:xfrm>
+          <a:prstGeom prst="rect">
+            <a:avLst/>
+          </a:prstGeom>
+          <a:solidFill>
+            <a:srgbClr val="111110"/>
+          </a:solidFill>
+          <a:ln>
+            <a:noFill/>
+          </a:ln>
+        </p:spPr>
+        <p:txBody>
+          <a:bodyPr/>
+          <a:lstStyle/>
+          <a:p>
+            <a:endParaRPr/>
+          </a:p>
+        </p:txBody>
+      </p:sp>
+      <p:sp>
+        <p:nvSpPr>
+          <p:cNvPr id="5013" name="SimReal 5013"/>
+          <p:cNvSpPr txBox="1"/>
+          <p:nvPr/>
+        </p:nvSpPr>
+        <p:spPr>
+          <a:xfrm>
+            <a:off x="6231636" y="1883664"/>
+            <a:ext cx="2567178" cy="658368"/>
+          </a:xfrm>
+          <a:prstGeom prst="rect">
+            <a:avLst/>
+          </a:prstGeom>
+          <a:noFill/>
+          <a:ln>
+            <a:noFill/>
+          </a:ln>
+        </p:spPr>
+        <p:txBody>
+          <a:bodyPr spcFirstLastPara="1" wrap="square" lIns="0" tIns="0" rIns="0" bIns="0" anchor="t" anchorCtr="0">
+            <a:noAutofit/>
+          </a:bodyPr>
+          <a:lstStyle/>
+          <a:p>
+            <a:pPr marL="0" marR="0" lvl="0" indent="0" algn="l" rtl="0">
+              <a:spcBef>
+                <a:spcPts val="0"/>
+              </a:spcBef>
+              <a:spcAft>
+                <a:spcPts val="0"/>
+              </a:spcAft>
+              <a:buNone/>
+            </a:pPr>
+            <a:r>
+              <a:rPr lang="en-US" sz="4000" b="0" i="0" u="none" strike="noStrike" cap="none">
+                <a:solidFill>
+                  <a:srgbClr val="111110"/>
+                </a:solidFill>
+                <a:latin typeface="Newsreader"/>
+                <a:ea typeface="Newsreader"/>
+                <a:cs typeface="Newsreader"/>
+                <a:sym typeface="Newsreader"/>
+              </a:rPr>
+              <a:t>$10B</a:t>
+            </a:r>
+          </a:p>
+        </p:txBody>
+      </p:sp>
+      <p:sp>
+        <p:nvSpPr>
+          <p:cNvPr id="5014" name="SimReal 5014"/>
+          <p:cNvSpPr txBox="1"/>
+          <p:nvPr/>
+        </p:nvSpPr>
+        <p:spPr>
+          <a:xfrm>
+            <a:off x="6231636" y="2596896"/>
+            <a:ext cx="2567178" cy="457200"/>
+          </a:xfrm>
+          <a:prstGeom prst="rect">
+            <a:avLst/>
+          </a:prstGeom>
+          <a:noFill/>
+          <a:ln>
+            <a:noFill/>
+          </a:ln>
+        </p:spPr>
+        <p:txBody>
+          <a:bodyPr spcFirstLastPara="1" wrap="square" lIns="0" tIns="0" rIns="0" bIns="0" anchor="t" anchorCtr="0">
+            <a:noAutofit/>
+          </a:bodyPr>
+          <a:lstStyle/>
+          <a:p>
+            <a:pPr marL="0" marR="0" lvl="0" indent="0" algn="l" rtl="0">
+              <a:lnSpc>
+                <a:spcPct val="110000"/>
+              </a:lnSpc>
+              <a:spcBef>
+                <a:spcPts val="0"/>
+              </a:spcBef>
+              <a:spcAft>
+                <a:spcPts val="0"/>
+              </a:spcAft>
+              <a:buNone/>
+            </a:pPr>
+            <a:r>
+              <a:rPr lang="en-US" sz="1150" b="0" i="0" u="none" strike="noStrike" cap="none">
+                <a:solidFill>
+                  <a:srgbClr val="33322F"/>
+                </a:solidFill>
+                <a:latin typeface="Instrument Sans"/>
+                <a:ea typeface="Instrument Sans"/>
+                <a:cs typeface="Instrument Sans"/>
+                <a:sym typeface="Instrument Sans"/>
+              </a:rPr>
+              <a:t>Instinct, up 4x in 33 days</a:t>
+            </a:r>
+          </a:p>
+        </p:txBody>
+      </p:sp>
+      <p:sp>
+        <p:nvSpPr>
+          <p:cNvPr id="5015" name="SimReal 5015"/>
+          <p:cNvSpPr/>
+          <p:nvPr/>
+        </p:nvSpPr>
+        <p:spPr>
+          <a:xfrm>
+            <a:off x="9073134" y="1755648"/>
+            <a:ext cx="2567178" cy="18288"/>
+          </a:xfrm>
+          <a:prstGeom prst="rect">
+            <a:avLst/>
+          </a:prstGeom>
+          <a:solidFill>
+            <a:srgbClr val="C2410C"/>
+          </a:solidFill>
+          <a:ln>
+            <a:noFill/>
+          </a:ln>
+        </p:spPr>
+        <p:txBody>
+          <a:bodyPr/>
+          <a:lstStyle/>
+          <a:p>
+            <a:endParaRPr/>
+          </a:p>
+        </p:txBody>
+      </p:sp>
+      <p:sp>
+        <p:nvSpPr>
+          <p:cNvPr id="5016" name="SimReal 5016"/>
+          <p:cNvSpPr txBox="1"/>
+          <p:nvPr/>
+        </p:nvSpPr>
+        <p:spPr>
+          <a:xfrm>
+            <a:off x="9073134" y="1883664"/>
+            <a:ext cx="2567178" cy="658368"/>
+          </a:xfrm>
+          <a:prstGeom prst="rect">
+            <a:avLst/>
+          </a:prstGeom>
+          <a:noFill/>
+          <a:ln>
+            <a:noFill/>
+          </a:ln>
+        </p:spPr>
+        <p:txBody>
+          <a:bodyPr spcFirstLastPara="1" wrap="square" lIns="0" tIns="0" rIns="0" bIns="0" anchor="t" anchorCtr="0">
+            <a:noAutofit/>
+          </a:bodyPr>
+          <a:lstStyle/>
+          <a:p>
+            <a:pPr marL="0" marR="0" lvl="0" indent="0" algn="l" rtl="0">
+              <a:spcBef>
+                <a:spcPts val="0"/>
+              </a:spcBef>
+              <a:spcAft>
+                <a:spcPts val="0"/>
+              </a:spcAft>
+              <a:buNone/>
+            </a:pPr>
+            <a:r>
+              <a:rPr lang="en-US" sz="4000" b="0" i="0" u="none" strike="noStrike" cap="none">
+                <a:solidFill>
+                  <a:srgbClr val="C2410C"/>
+                </a:solidFill>
+                <a:latin typeface="Newsreader"/>
+                <a:ea typeface="Newsreader"/>
+                <a:cs typeface="Newsreader"/>
+                <a:sym typeface="Newsreader"/>
+              </a:rPr>
+              <a:t>16.1%</a:t>
+            </a:r>
+          </a:p>
+        </p:txBody>
+      </p:sp>
+      <p:sp>
+        <p:nvSpPr>
+          <p:cNvPr id="5017" name="SimReal 5017"/>
+          <p:cNvSpPr txBox="1"/>
+          <p:nvPr/>
+        </p:nvSpPr>
+        <p:spPr>
+          <a:xfrm>
+            <a:off x="9073134" y="2596896"/>
+            <a:ext cx="2567178" cy="457200"/>
+          </a:xfrm>
+          <a:prstGeom prst="rect">
+            <a:avLst/>
+          </a:prstGeom>
+          <a:noFill/>
+          <a:ln>
+            <a:noFill/>
+          </a:ln>
+        </p:spPr>
+        <p:txBody>
+          <a:bodyPr spcFirstLastPara="1" wrap="square" lIns="0" tIns="0" rIns="0" bIns="0" anchor="t" anchorCtr="0">
+            <a:noAutofit/>
+          </a:bodyPr>
+          <a:lstStyle/>
+          <a:p>
+            <a:pPr marL="0" marR="0" lvl="0" indent="0" algn="l" rtl="0">
+              <a:lnSpc>
+                <a:spcPct val="110000"/>
+              </a:lnSpc>
+              <a:spcBef>
+                <a:spcPts val="0"/>
+              </a:spcBef>
+              <a:spcAft>
+                <a:spcPts val="0"/>
+              </a:spcAft>
+              <a:buNone/>
+            </a:pPr>
+            <a:r>
+              <a:rPr lang="en-US" sz="1150" b="0" i="0" u="none" strike="noStrike" cap="none">
+                <a:solidFill>
+                  <a:srgbClr val="33322F"/>
+                </a:solidFill>
+                <a:latin typeface="Instrument Sans"/>
+                <a:ea typeface="Instrument Sans"/>
+                <a:cs typeface="Instrument Sans"/>
+                <a:sym typeface="Instrument Sans"/>
+              </a:rPr>
+              <a:t>Yet the best model completes 16.1%</a:t>
+            </a:r>
+          </a:p>
+          <a:p>
+            <a:pPr marL="0" marR="0" lvl="0" indent="0" algn="l" rtl="0">
+              <a:lnSpc>
+                <a:spcPct val="110000"/>
+              </a:lnSpc>
+              <a:spcBef>
+                <a:spcPts val="0"/>
+              </a:spcBef>
+              <a:spcAft>
+                <a:spcPts val="0"/>
+              </a:spcAft>
+              <a:buNone/>
+            </a:pPr>
+            <a:r>
+              <a:rPr lang="en-US" sz="1150" b="0" i="0" u="none" strike="noStrike" cap="none">
+                <a:solidFill>
+                  <a:srgbClr val="33322F"/>
+                </a:solidFill>
+                <a:latin typeface="Instrument Sans"/>
+                <a:ea typeface="Instrument Sans"/>
+                <a:cs typeface="Instrument Sans"/>
+                <a:sym typeface="Instrument Sans"/>
+              </a:rPr>
+              <a:t>of real freelance projects</a:t>
+            </a:r>
+          </a:p>
+        </p:txBody>
+      </p:sp>
+      <p:sp>
+        <p:nvSpPr>
+          <p:cNvPr id="5018" name="SimReal 5018"/>
+          <p:cNvSpPr txBox="1"/>
+          <p:nvPr/>
+        </p:nvSpPr>
+        <p:spPr>
+          <a:xfrm>
+            <a:off x="548640" y="3529584"/>
+            <a:ext cx="7315200" cy="201168"/>
+          </a:xfrm>
+          <a:prstGeom prst="rect">
+            <a:avLst/>
+          </a:prstGeom>
+          <a:noFill/>
+          <a:ln>
+            <a:noFill/>
+          </a:ln>
+        </p:spPr>
+        <p:txBody>
+          <a:bodyPr spcFirstLastPara="1" wrap="square" lIns="0" tIns="0" rIns="0" bIns="0" anchor="t" anchorCtr="0">
+            <a:noAutofit/>
+          </a:bodyPr>
+          <a:lstStyle/>
+          <a:p>
+            <a:pPr marL="0" marR="0" lvl="0" indent="0" algn="l" rtl="0">
+              <a:spcBef>
+                <a:spcPts val="0"/>
+              </a:spcBef>
+              <a:spcAft>
+                <a:spcPts val="0"/>
+              </a:spcAft>
+              <a:buNone/>
+            </a:pPr>
+            <a:r>
+              <a:rPr lang="en-US" sz="1000" b="0" i="0" u="none" strike="noStrike" cap="none">
                 <a:solidFill>
                   <a:srgbClr val="6E6C66"/>
                 </a:solidFill>
@@ -30554,662 +31094,119 @@
                 <a:cs typeface="IBM Plex Mono"/>
                 <a:sym typeface="IBM Plex Mono"/>
               </a:rPr>
-              <a:t>Meta · Sep 8</a:t>
-            </a:r>
-          </a:p>
-        </p:txBody>
-      </p:sp>
-      <p:sp>
-        <p:nvSpPr>
-          <p:cNvPr id="5008" name="SimReal 5008"/>
-          <p:cNvSpPr txBox="1"/>
-          <p:nvPr/>
-        </p:nvSpPr>
-        <p:spPr>
-          <a:xfrm>
-            <a:off x="548640" y="2084832"/>
-            <a:ext cx="2567178" cy="566928"/>
-          </a:xfrm>
-          <a:prstGeom prst="rect">
-            <a:avLst/>
-          </a:prstGeom>
-          <a:noFill/>
-          <a:ln>
-            <a:noFill/>
-          </a:ln>
-        </p:spPr>
-        <p:txBody>
-          <a:bodyPr spcFirstLastPara="1" wrap="square" lIns="0" tIns="0" rIns="0" bIns="0" anchor="t" anchorCtr="0">
-            <a:noAutofit/>
-          </a:bodyPr>
-          <a:lstStyle/>
-          <a:p>
-            <a:pPr marL="0" marR="0" lvl="0" indent="0" algn="l" rtl="0">
-              <a:spcBef>
-                <a:spcPts val="0"/>
-              </a:spcBef>
-              <a:spcAft>
-                <a:spcPts val="0"/>
-              </a:spcAft>
-              <a:buNone/>
-            </a:pPr>
-            <a:r>
-              <a:rPr lang="en-US" sz="3200" b="0" i="0" u="none" strike="noStrike" cap="none">
-                <a:solidFill>
-                  <a:srgbClr val="C2410C"/>
+              <a:t>So they practice in our worlds first</a:t>
+            </a:r>
+          </a:p>
+        </p:txBody>
+      </p:sp>
+      <p:sp>
+        <p:nvSpPr>
+          <p:cNvPr id="5019" name="SimReal 5019"/>
+          <p:cNvSpPr txBox="1"/>
+          <p:nvPr/>
+        </p:nvSpPr>
+        <p:spPr>
+          <a:xfrm>
+            <a:off x="548640" y="3767328"/>
+            <a:ext cx="11091672" cy="457200"/>
+          </a:xfrm>
+          <a:prstGeom prst="rect">
+            <a:avLst/>
+          </a:prstGeom>
+          <a:noFill/>
+          <a:ln>
+            <a:noFill/>
+          </a:ln>
+        </p:spPr>
+        <p:txBody>
+          <a:bodyPr spcFirstLastPara="1" wrap="square" lIns="0" tIns="0" rIns="0" bIns="0" anchor="ctr" anchorCtr="0">
+            <a:noAutofit/>
+          </a:bodyPr>
+          <a:lstStyle/>
+          <a:p>
+            <a:pPr marL="0" marR="0" lvl="0" indent="0" algn="l" rtl="0">
+              <a:spcBef>
+                <a:spcPts val="0"/>
+              </a:spcBef>
+              <a:spcAft>
+                <a:spcPts val="0"/>
+              </a:spcAft>
+              <a:buNone/>
+            </a:pPr>
+            <a:r>
+              <a:rPr lang="en-US" sz="2200" b="0" i="0" u="none" strike="noStrike" cap="none">
+                <a:solidFill>
+                  <a:srgbClr val="111110"/>
                 </a:solidFill>
                 <a:latin typeface="Newsreader"/>
                 <a:ea typeface="Newsreader"/>
                 <a:cs typeface="Newsreader"/>
                 <a:sym typeface="Newsreader"/>
               </a:rPr>
-              <a:t>Muse</a:t>
-            </a:r>
-          </a:p>
-        </p:txBody>
-      </p:sp>
-      <p:sp>
-        <p:nvSpPr>
-          <p:cNvPr id="5009" name="SimReal 5009"/>
-          <p:cNvSpPr txBox="1"/>
-          <p:nvPr/>
-        </p:nvSpPr>
-        <p:spPr>
-          <a:xfrm>
-            <a:off x="548640" y="2706624"/>
-            <a:ext cx="2567178" cy="457200"/>
-          </a:xfrm>
-          <a:prstGeom prst="rect">
-            <a:avLst/>
-          </a:prstGeom>
-          <a:noFill/>
-          <a:ln>
-            <a:noFill/>
-          </a:ln>
-        </p:spPr>
-        <p:txBody>
-          <a:bodyPr spcFirstLastPara="1" wrap="square" lIns="0" tIns="0" rIns="0" bIns="0" anchor="t" anchorCtr="0">
-            <a:noAutofit/>
-          </a:bodyPr>
-          <a:lstStyle/>
-          <a:p>
-            <a:pPr marL="0" marR="0" lvl="0" indent="0" algn="l" rtl="0">
-              <a:lnSpc>
-                <a:spcPct val="110000"/>
-              </a:lnSpc>
-              <a:spcBef>
-                <a:spcPts val="0"/>
-              </a:spcBef>
-              <a:spcAft>
-                <a:spcPts val="0"/>
-              </a:spcAft>
-              <a:buNone/>
-            </a:pPr>
-            <a:r>
-              <a:rPr lang="en-US" sz="1000" b="0" i="0" u="none" strike="noStrike" cap="none">
-                <a:solidFill>
-                  <a:srgbClr val="33322F"/>
-                </a:solidFill>
-                <a:latin typeface="Instrument Sans"/>
-                <a:ea typeface="Instrument Sans"/>
-                <a:cs typeface="Instrument Sans"/>
-                <a:sym typeface="Instrument Sans"/>
-              </a:rPr>
-              <a:t>Books, shops and schedules for you;</a:t>
-            </a:r>
-          </a:p>
-          <a:p>
-            <a:pPr marL="0" marR="0" lvl="0" indent="0" algn="l" rtl="0">
-              <a:lnSpc>
-                <a:spcPct val="110000"/>
-              </a:lnSpc>
-              <a:spcBef>
-                <a:spcPts val="0"/>
-              </a:spcBef>
-              <a:spcAft>
-                <a:spcPts val="0"/>
-              </a:spcAft>
-              <a:buNone/>
-            </a:pPr>
-            <a:r>
-              <a:rPr lang="en-US" sz="1000" b="0" i="0" u="none" strike="noStrike" cap="none">
-                <a:solidFill>
-                  <a:srgbClr val="33322F"/>
-                </a:solidFill>
-                <a:latin typeface="Instrument Sans"/>
-                <a:ea typeface="Instrument Sans"/>
-                <a:cs typeface="Instrument Sans"/>
-                <a:sym typeface="Instrument Sans"/>
-              </a:rPr>
-              <a:t>blocked by Amazon two weeks later</a:t>
-            </a:r>
-          </a:p>
-        </p:txBody>
-      </p:sp>
-      <p:sp>
-        <p:nvSpPr>
-          <p:cNvPr id="5010" name="SimReal 5010"/>
-          <p:cNvSpPr/>
-          <p:nvPr/>
-        </p:nvSpPr>
-        <p:spPr>
-          <a:xfrm>
-            <a:off x="3390138" y="1755648"/>
-            <a:ext cx="2567178" cy="18288"/>
-          </a:xfrm>
-          <a:prstGeom prst="rect">
-            <a:avLst/>
-          </a:prstGeom>
-          <a:solidFill>
-            <a:srgbClr val="111110"/>
-          </a:solidFill>
-          <a:ln>
-            <a:noFill/>
-          </a:ln>
-        </p:spPr>
-        <p:txBody>
-          <a:bodyPr/>
-          <a:lstStyle/>
-          <a:p>
-            <a:endParaRPr/>
-          </a:p>
-        </p:txBody>
-      </p:sp>
-      <p:sp>
-        <p:nvSpPr>
-          <p:cNvPr id="5011" name="SimReal 5011"/>
-          <p:cNvSpPr txBox="1"/>
-          <p:nvPr/>
-        </p:nvSpPr>
-        <p:spPr>
-          <a:xfrm>
-            <a:off x="3390138" y="1865376"/>
-            <a:ext cx="2567178" cy="201168"/>
-          </a:xfrm>
-          <a:prstGeom prst="rect">
-            <a:avLst/>
-          </a:prstGeom>
-          <a:noFill/>
-          <a:ln>
-            <a:noFill/>
-          </a:ln>
-        </p:spPr>
-        <p:txBody>
-          <a:bodyPr spcFirstLastPara="1" wrap="square" lIns="0" tIns="0" rIns="0" bIns="0" anchor="t" anchorCtr="0">
-            <a:noAutofit/>
-          </a:bodyPr>
-          <a:lstStyle/>
-          <a:p>
-            <a:pPr marL="0" marR="0" lvl="0" indent="0" algn="l" rtl="0">
-              <a:spcBef>
-                <a:spcPts val="0"/>
-              </a:spcBef>
-              <a:spcAft>
-                <a:spcPts val="0"/>
-              </a:spcAft>
-              <a:buNone/>
-            </a:pPr>
-            <a:r>
-              <a:rPr lang="en-US" sz="950" b="0" i="0" u="none" strike="noStrike" cap="none">
+              <a:t>Practice</a:t>
+            </a:r>
+            <a:r>
+              <a:rPr lang="en-US" sz="1600" b="0" i="0" u="none" strike="noStrike" cap="none">
                 <a:solidFill>
                   <a:srgbClr val="6E6C66"/>
                 </a:solidFill>
-                <a:latin typeface="IBM Plex Mono"/>
-                <a:ea typeface="IBM Plex Mono"/>
-                <a:cs typeface="IBM Plex Mono"/>
-                <a:sym typeface="IBM Plex Mono"/>
-              </a:rPr>
-              <a:t>OpenAI · Sep 29</a:t>
-            </a:r>
-          </a:p>
-        </p:txBody>
-      </p:sp>
-      <p:sp>
-        <p:nvSpPr>
-          <p:cNvPr id="5012" name="SimReal 5012"/>
-          <p:cNvSpPr txBox="1"/>
-          <p:nvPr/>
-        </p:nvSpPr>
-        <p:spPr>
-          <a:xfrm>
-            <a:off x="3390138" y="2084832"/>
-            <a:ext cx="2567178" cy="566928"/>
-          </a:xfrm>
-          <a:prstGeom prst="rect">
-            <a:avLst/>
-          </a:prstGeom>
-          <a:noFill/>
-          <a:ln>
-            <a:noFill/>
-          </a:ln>
-        </p:spPr>
-        <p:txBody>
-          <a:bodyPr spcFirstLastPara="1" wrap="square" lIns="0" tIns="0" rIns="0" bIns="0" anchor="t" anchorCtr="0">
-            <a:noAutofit/>
-          </a:bodyPr>
-          <a:lstStyle/>
-          <a:p>
-            <a:pPr marL="0" marR="0" lvl="0" indent="0" algn="l" rtl="0">
-              <a:spcBef>
-                <a:spcPts val="0"/>
-              </a:spcBef>
-              <a:spcAft>
-                <a:spcPts val="0"/>
-              </a:spcAft>
-              <a:buNone/>
-            </a:pPr>
-            <a:r>
-              <a:rPr lang="en-US" sz="3200" b="0" i="0" u="none" strike="noStrike" cap="none">
-                <a:solidFill>
-                  <a:srgbClr val="C2410C"/>
+                <a:latin typeface="Instrument Sans"/>
+                <a:ea typeface="Instrument Sans"/>
+                <a:cs typeface="Instrument Sans"/>
+                <a:sym typeface="Instrument Sans"/>
+              </a:rPr>
+              <a:t>   →   </a:t>
+            </a:r>
+            <a:r>
+              <a:rPr lang="en-US" sz="2200" b="0" i="0" u="none" strike="noStrike" cap="none">
+                <a:solidFill>
+                  <a:srgbClr val="111110"/>
                 </a:solidFill>
                 <a:latin typeface="Newsreader"/>
                 <a:ea typeface="Newsreader"/>
                 <a:cs typeface="Newsreader"/>
                 <a:sym typeface="Newsreader"/>
               </a:rPr>
-              <a:t>Dots</a:t>
-            </a:r>
-          </a:p>
-        </p:txBody>
-      </p:sp>
-      <p:sp>
-        <p:nvSpPr>
-          <p:cNvPr id="5013" name="SimReal 5013"/>
-          <p:cNvSpPr txBox="1"/>
-          <p:nvPr/>
-        </p:nvSpPr>
-        <p:spPr>
-          <a:xfrm>
-            <a:off x="3390138" y="2706624"/>
-            <a:ext cx="2567178" cy="457200"/>
-          </a:xfrm>
-          <a:prstGeom prst="rect">
-            <a:avLst/>
-          </a:prstGeom>
-          <a:noFill/>
-          <a:ln>
-            <a:noFill/>
-          </a:ln>
-        </p:spPr>
-        <p:txBody>
-          <a:bodyPr spcFirstLastPara="1" wrap="square" lIns="0" tIns="0" rIns="0" bIns="0" anchor="t" anchorCtr="0">
-            <a:noAutofit/>
-          </a:bodyPr>
-          <a:lstStyle/>
-          <a:p>
-            <a:pPr marL="0" marR="0" lvl="0" indent="0" algn="l" rtl="0">
-              <a:lnSpc>
-                <a:spcPct val="110000"/>
-              </a:lnSpc>
-              <a:spcBef>
-                <a:spcPts val="0"/>
-              </a:spcBef>
-              <a:spcAft>
-                <a:spcPts val="0"/>
-              </a:spcAft>
-              <a:buNone/>
-            </a:pPr>
-            <a:r>
-              <a:rPr lang="en-US" sz="1000" b="0" i="0" u="none" strike="noStrike" cap="none">
-                <a:solidFill>
-                  <a:srgbClr val="33322F"/>
-                </a:solidFill>
-                <a:latin typeface="Instrument Sans"/>
-                <a:ea typeface="Instrument Sans"/>
-                <a:cs typeface="Instrument Sans"/>
-                <a:sym typeface="Instrument Sans"/>
-              </a:rPr>
-              <a:t>Always-on personal agents that</a:t>
-            </a:r>
-          </a:p>
-          <a:p>
-            <a:pPr marL="0" marR="0" lvl="0" indent="0" algn="l" rtl="0">
-              <a:lnSpc>
-                <a:spcPct val="110000"/>
-              </a:lnSpc>
-              <a:spcBef>
-                <a:spcPts val="0"/>
-              </a:spcBef>
-              <a:spcAft>
-                <a:spcPts val="0"/>
-              </a:spcAft>
-              <a:buNone/>
-            </a:pPr>
-            <a:r>
-              <a:rPr lang="en-US" sz="1000" b="0" i="0" u="none" strike="noStrike" cap="none">
-                <a:solidFill>
-                  <a:srgbClr val="33322F"/>
-                </a:solidFill>
-                <a:latin typeface="Instrument Sans"/>
-                <a:ea typeface="Instrument Sans"/>
-                <a:cs typeface="Instrument Sans"/>
-                <a:sym typeface="Instrument Sans"/>
-              </a:rPr>
-              <a:t>keep working in the background</a:t>
-            </a:r>
-          </a:p>
-        </p:txBody>
-      </p:sp>
-      <p:sp>
-        <p:nvSpPr>
-          <p:cNvPr id="5014" name="SimReal 5014"/>
-          <p:cNvSpPr/>
-          <p:nvPr/>
-        </p:nvSpPr>
-        <p:spPr>
-          <a:xfrm>
-            <a:off x="6231636" y="1755648"/>
-            <a:ext cx="2567178" cy="18288"/>
-          </a:xfrm>
-          <a:prstGeom prst="rect">
-            <a:avLst/>
-          </a:prstGeom>
-          <a:solidFill>
-            <a:srgbClr val="111110"/>
-          </a:solidFill>
-          <a:ln>
-            <a:noFill/>
-          </a:ln>
-        </p:spPr>
-        <p:txBody>
-          <a:bodyPr/>
-          <a:lstStyle/>
-          <a:p>
-            <a:endParaRPr/>
-          </a:p>
-        </p:txBody>
-      </p:sp>
-      <p:sp>
-        <p:nvSpPr>
-          <p:cNvPr id="5015" name="SimReal 5015"/>
-          <p:cNvSpPr txBox="1"/>
-          <p:nvPr/>
-        </p:nvSpPr>
-        <p:spPr>
-          <a:xfrm>
-            <a:off x="6231636" y="1865376"/>
-            <a:ext cx="2567178" cy="201168"/>
-          </a:xfrm>
-          <a:prstGeom prst="rect">
-            <a:avLst/>
-          </a:prstGeom>
-          <a:noFill/>
-          <a:ln>
-            <a:noFill/>
-          </a:ln>
-        </p:spPr>
-        <p:txBody>
-          <a:bodyPr spcFirstLastPara="1" wrap="square" lIns="0" tIns="0" rIns="0" bIns="0" anchor="t" anchorCtr="0">
-            <a:noAutofit/>
-          </a:bodyPr>
-          <a:lstStyle/>
-          <a:p>
-            <a:pPr marL="0" marR="0" lvl="0" indent="0" algn="l" rtl="0">
-              <a:spcBef>
-                <a:spcPts val="0"/>
-              </a:spcBef>
-              <a:spcAft>
-                <a:spcPts val="0"/>
-              </a:spcAft>
-              <a:buNone/>
-            </a:pPr>
-            <a:r>
-              <a:rPr lang="en-US" sz="950" b="0" i="0" u="none" strike="noStrike" cap="none">
+              <a:t>Real outcomes settle</a:t>
+            </a:r>
+            <a:r>
+              <a:rPr lang="en-US" sz="1600" b="0" i="0" u="none" strike="noStrike" cap="none">
                 <a:solidFill>
                   <a:srgbClr val="6E6C66"/>
                 </a:solidFill>
-                <a:latin typeface="IBM Plex Mono"/>
-                <a:ea typeface="IBM Plex Mono"/>
-                <a:cs typeface="IBM Plex Mono"/>
-                <a:sym typeface="IBM Plex Mono"/>
-              </a:rPr>
-              <a:t>Instinct · Sep 28</a:t>
-            </a:r>
-          </a:p>
-        </p:txBody>
-      </p:sp>
-      <p:sp>
-        <p:nvSpPr>
-          <p:cNvPr id="5016" name="SimReal 5016"/>
-          <p:cNvSpPr txBox="1"/>
-          <p:nvPr/>
-        </p:nvSpPr>
-        <p:spPr>
-          <a:xfrm>
-            <a:off x="6231636" y="2084832"/>
-            <a:ext cx="2567178" cy="566928"/>
-          </a:xfrm>
-          <a:prstGeom prst="rect">
-            <a:avLst/>
-          </a:prstGeom>
-          <a:noFill/>
-          <a:ln>
-            <a:noFill/>
-          </a:ln>
-        </p:spPr>
-        <p:txBody>
-          <a:bodyPr spcFirstLastPara="1" wrap="square" lIns="0" tIns="0" rIns="0" bIns="0" anchor="t" anchorCtr="0">
-            <a:noAutofit/>
-          </a:bodyPr>
-          <a:lstStyle/>
-          <a:p>
-            <a:pPr marL="0" marR="0" lvl="0" indent="0" algn="l" rtl="0">
-              <a:spcBef>
-                <a:spcPts val="0"/>
-              </a:spcBef>
-              <a:spcAft>
-                <a:spcPts val="0"/>
-              </a:spcAft>
-              <a:buNone/>
-            </a:pPr>
-            <a:r>
-              <a:rPr lang="en-US" sz="3200" b="0" i="0" u="none" strike="noStrike" cap="none">
-                <a:solidFill>
-                  <a:srgbClr val="C2410C"/>
+                <a:latin typeface="Instrument Sans"/>
+                <a:ea typeface="Instrument Sans"/>
+                <a:cs typeface="Instrument Sans"/>
+                <a:sym typeface="Instrument Sans"/>
+              </a:rPr>
+              <a:t>   →   </a:t>
+            </a:r>
+            <a:r>
+              <a:rPr lang="en-US" sz="2200" b="0" i="0" u="none" strike="noStrike" cap="none">
+                <a:solidFill>
+                  <a:srgbClr val="111110"/>
                 </a:solidFill>
                 <a:latin typeface="Newsreader"/>
                 <a:ea typeface="Newsreader"/>
                 <a:cs typeface="Newsreader"/>
                 <a:sym typeface="Newsreader"/>
               </a:rPr>
-              <a:t>$10B</a:t>
-            </a:r>
-          </a:p>
-        </p:txBody>
-      </p:sp>
-      <p:sp>
-        <p:nvSpPr>
-          <p:cNvPr id="5017" name="SimReal 5017"/>
-          <p:cNvSpPr txBox="1"/>
-          <p:nvPr/>
-        </p:nvSpPr>
-        <p:spPr>
-          <a:xfrm>
-            <a:off x="6231636" y="2706624"/>
-            <a:ext cx="2567178" cy="457200"/>
-          </a:xfrm>
-          <a:prstGeom prst="rect">
-            <a:avLst/>
-          </a:prstGeom>
-          <a:noFill/>
-          <a:ln>
-            <a:noFill/>
-          </a:ln>
-        </p:spPr>
-        <p:txBody>
-          <a:bodyPr spcFirstLastPara="1" wrap="square" lIns="0" tIns="0" rIns="0" bIns="0" anchor="t" anchorCtr="0">
-            <a:noAutofit/>
-          </a:bodyPr>
-          <a:lstStyle/>
-          <a:p>
-            <a:pPr marL="0" marR="0" lvl="0" indent="0" algn="l" rtl="0">
-              <a:lnSpc>
-                <a:spcPct val="110000"/>
-              </a:lnSpc>
-              <a:spcBef>
-                <a:spcPts val="0"/>
-              </a:spcBef>
-              <a:spcAft>
-                <a:spcPts val="0"/>
-              </a:spcAft>
-              <a:buNone/>
-            </a:pPr>
-            <a:r>
-              <a:rPr lang="en-US" sz="1000" b="0" i="0" u="none" strike="noStrike" cap="none">
-                <a:solidFill>
-                  <a:srgbClr val="33322F"/>
-                </a:solidFill>
-                <a:latin typeface="Instrument Sans"/>
-                <a:ea typeface="Instrument Sans"/>
-                <a:cs typeface="Instrument Sans"/>
-                <a:sym typeface="Instrument Sans"/>
-              </a:rPr>
-              <a:t>Valuation: $2.5B to $10B in 33 days;</a:t>
-            </a:r>
-          </a:p>
-          <a:p>
-            <a:pPr marL="0" marR="0" lvl="0" indent="0" algn="l" rtl="0">
-              <a:lnSpc>
-                <a:spcPct val="110000"/>
-              </a:lnSpc>
-              <a:spcBef>
-                <a:spcPts val="0"/>
-              </a:spcBef>
-              <a:spcAft>
-                <a:spcPts val="0"/>
-              </a:spcAft>
-              <a:buNone/>
-            </a:pPr>
-            <a:r>
-              <a:rPr lang="en-US" sz="1000" b="0" i="0" u="none" strike="noStrike" cap="none">
-                <a:solidFill>
-                  <a:srgbClr val="33322F"/>
-                </a:solidFill>
-                <a:latin typeface="Instrument Sans"/>
-                <a:ea typeface="Instrument Sans"/>
-                <a:cs typeface="Instrument Sans"/>
-                <a:sym typeface="Instrument Sans"/>
-              </a:rPr>
-              <a:t>Sequoia, Benchmark, Coatue</a:t>
-            </a:r>
-          </a:p>
-        </p:txBody>
-      </p:sp>
-      <p:sp>
-        <p:nvSpPr>
-          <p:cNvPr id="5018" name="SimReal 5018"/>
-          <p:cNvSpPr/>
-          <p:nvPr/>
-        </p:nvSpPr>
-        <p:spPr>
-          <a:xfrm>
-            <a:off x="9073134" y="1755648"/>
-            <a:ext cx="2567178" cy="18288"/>
-          </a:xfrm>
-          <a:prstGeom prst="rect">
-            <a:avLst/>
-          </a:prstGeom>
-          <a:solidFill>
-            <a:srgbClr val="111110"/>
-          </a:solidFill>
-          <a:ln>
-            <a:noFill/>
-          </a:ln>
-        </p:spPr>
-        <p:txBody>
-          <a:bodyPr/>
-          <a:lstStyle/>
-          <a:p>
-            <a:endParaRPr/>
-          </a:p>
-        </p:txBody>
-      </p:sp>
-      <p:sp>
-        <p:nvSpPr>
-          <p:cNvPr id="5019" name="SimReal 5019"/>
-          <p:cNvSpPr txBox="1"/>
-          <p:nvPr/>
-        </p:nvSpPr>
-        <p:spPr>
-          <a:xfrm>
-            <a:off x="9073134" y="1865376"/>
-            <a:ext cx="2567178" cy="201168"/>
-          </a:xfrm>
-          <a:prstGeom prst="rect">
-            <a:avLst/>
-          </a:prstGeom>
-          <a:noFill/>
-          <a:ln>
-            <a:noFill/>
-          </a:ln>
-        </p:spPr>
-        <p:txBody>
-          <a:bodyPr spcFirstLastPara="1" wrap="square" lIns="0" tIns="0" rIns="0" bIns="0" anchor="t" anchorCtr="0">
-            <a:noAutofit/>
-          </a:bodyPr>
-          <a:lstStyle/>
-          <a:p>
-            <a:pPr marL="0" marR="0" lvl="0" indent="0" algn="l" rtl="0">
-              <a:spcBef>
-                <a:spcPts val="0"/>
-              </a:spcBef>
-              <a:spcAft>
-                <a:spcPts val="0"/>
-              </a:spcAft>
-              <a:buNone/>
-            </a:pPr>
-            <a:r>
-              <a:rPr lang="en-US" sz="950" b="0" i="0" u="none" strike="noStrike" cap="none">
+              <a:t>Agents improve</a:t>
+            </a:r>
+            <a:r>
+              <a:rPr lang="en-US" sz="1600" b="0" i="0" u="none" strike="noStrike" cap="none">
                 <a:solidFill>
                   <a:srgbClr val="6E6C66"/>
                 </a:solidFill>
-                <a:latin typeface="IBM Plex Mono"/>
-                <a:ea typeface="IBM Plex Mono"/>
-                <a:cs typeface="IBM Plex Mono"/>
-                <a:sym typeface="IBM Plex Mono"/>
-              </a:rPr>
-              <a:t>Still falling short</a:t>
-            </a:r>
-          </a:p>
-        </p:txBody>
-      </p:sp>
-      <p:sp>
-        <p:nvSpPr>
-          <p:cNvPr id="5020" name="SimReal 5020"/>
-          <p:cNvSpPr txBox="1"/>
-          <p:nvPr/>
-        </p:nvSpPr>
-        <p:spPr>
-          <a:xfrm>
-            <a:off x="9073134" y="2084832"/>
-            <a:ext cx="2567178" cy="566928"/>
-          </a:xfrm>
-          <a:prstGeom prst="rect">
-            <a:avLst/>
-          </a:prstGeom>
-          <a:noFill/>
-          <a:ln>
-            <a:noFill/>
-          </a:ln>
-        </p:spPr>
-        <p:txBody>
-          <a:bodyPr spcFirstLastPara="1" wrap="square" lIns="0" tIns="0" rIns="0" bIns="0" anchor="t" anchorCtr="0">
-            <a:noAutofit/>
-          </a:bodyPr>
-          <a:lstStyle/>
-          <a:p>
-            <a:pPr marL="0" marR="0" lvl="0" indent="0" algn="l" rtl="0">
-              <a:spcBef>
-                <a:spcPts val="0"/>
-              </a:spcBef>
-              <a:spcAft>
-                <a:spcPts val="0"/>
-              </a:spcAft>
-              <a:buNone/>
-            </a:pPr>
-            <a:r>
-              <a:rPr lang="en-US" sz="3200" b="0" i="0" u="none" strike="noStrike" cap="none">
+                <a:latin typeface="Instrument Sans"/>
+                <a:ea typeface="Instrument Sans"/>
+                <a:cs typeface="Instrument Sans"/>
+                <a:sym typeface="Instrument Sans"/>
+              </a:rPr>
+              <a:t>   →   </a:t>
+            </a:r>
+            <a:r>
+              <a:rPr lang="en-US" sz="2200" b="0" i="0" u="none" strike="noStrike" cap="none">
                 <a:solidFill>
                   <a:srgbClr val="C2410C"/>
                 </a:solidFill>
@@ -31218,7 +31215,56 @@
                 <a:cs typeface="Newsreader"/>
                 <a:sym typeface="Newsreader"/>
               </a:rPr>
-              <a:t>16.1%</a:t>
+              <a:t>Data goes to labs</a:t>
+            </a:r>
+          </a:p>
+        </p:txBody>
+      </p:sp>
+      <p:sp>
+        <p:nvSpPr>
+          <p:cNvPr id="5020" name="SimReal 5020"/>
+          <p:cNvSpPr txBox="1"/>
+          <p:nvPr/>
+        </p:nvSpPr>
+        <p:spPr>
+          <a:xfrm>
+            <a:off x="548640" y="4297680"/>
+            <a:ext cx="11091672" cy="274320"/>
+          </a:xfrm>
+          <a:prstGeom prst="rect">
+            <a:avLst/>
+          </a:prstGeom>
+          <a:noFill/>
+          <a:ln>
+            <a:noFill/>
+          </a:ln>
+        </p:spPr>
+        <p:txBody>
+          <a:bodyPr spcFirstLastPara="1" wrap="square" lIns="0" tIns="0" rIns="0" bIns="0" anchor="t" anchorCtr="0">
+            <a:noAutofit/>
+          </a:bodyPr>
+          <a:lstStyle/>
+          <a:p>
+            <a:pPr marL="0" marR="0" lvl="0" indent="0" algn="l" rtl="0">
+              <a:spcBef>
+                <a:spcPts val="0"/>
+              </a:spcBef>
+              <a:spcAft>
+                <a:spcPts val="0"/>
+              </a:spcAft>
+              <a:buNone/>
+            </a:pPr>
+            <a:r>
+              <a:rPr lang="en-US" sz="1200" b="0" i="0" u="none" strike="noStrike" cap="none">
+                <a:solidFill>
+                  <a:srgbClr val="6E6C66"/>
+                </a:solidFill>
+                <a:latin typeface="Instrument Sans"/>
+                <a:ea typeface="Instrument Sans"/>
+                <a:cs typeface="Instrument Sans"/>
+                <a:sym typeface="Instrument Sans"/>
+              </a:rPr>
+              <a:t>Our trading world already runs this loop: Qwen3.8-27B traded up to 12% better. This round we open trading and event prediction to personal agents.</a:t>
             </a:r>
           </a:p>
         </p:txBody>
@@ -31231,86 +31277,8 @@
         </p:nvSpPr>
         <p:spPr>
           <a:xfrm>
-            <a:off x="9073134" y="2706624"/>
-            <a:ext cx="2567178" cy="457200"/>
-          </a:xfrm>
-          <a:prstGeom prst="rect">
-            <a:avLst/>
-          </a:prstGeom>
-          <a:noFill/>
-          <a:ln>
-            <a:noFill/>
-          </a:ln>
-        </p:spPr>
-        <p:txBody>
-          <a:bodyPr spcFirstLastPara="1" wrap="square" lIns="0" tIns="0" rIns="0" bIns="0" anchor="t" anchorCtr="0">
-            <a:noAutofit/>
-          </a:bodyPr>
-          <a:lstStyle/>
-          <a:p>
-            <a:pPr marL="0" marR="0" lvl="0" indent="0" algn="l" rtl="0">
-              <a:lnSpc>
-                <a:spcPct val="110000"/>
-              </a:lnSpc>
-              <a:spcBef>
-                <a:spcPts val="0"/>
-              </a:spcBef>
-              <a:spcAft>
-                <a:spcPts val="0"/>
-              </a:spcAft>
-              <a:buNone/>
-            </a:pPr>
-            <a:r>
-              <a:rPr lang="en-US" sz="1000" b="0" i="0" u="none" strike="noStrike" cap="none">
-                <a:solidFill>
-                  <a:srgbClr val="33322F"/>
-                </a:solidFill>
-                <a:latin typeface="Instrument Sans"/>
-                <a:ea typeface="Instrument Sans"/>
-                <a:cs typeface="Instrument Sans"/>
-                <a:sym typeface="Instrument Sans"/>
-              </a:rPr>
-              <a:t>The best model completes 16.1% of real</a:t>
-            </a:r>
-          </a:p>
-          <a:p>
-            <a:pPr marL="0" marR="0" lvl="0" indent="0" algn="l" rtl="0">
-              <a:lnSpc>
-                <a:spcPct val="110000"/>
-              </a:lnSpc>
-              <a:spcBef>
-                <a:spcPts val="0"/>
-              </a:spcBef>
-              <a:spcAft>
-                <a:spcPts val="0"/>
-              </a:spcAft>
-              <a:buNone/>
-            </a:pPr>
-            <a:r>
-              <a:rPr lang="en-US" sz="1000" b="0" i="0" u="none" strike="noStrike" cap="none">
-                <a:solidFill>
-                  <a:srgbClr val="33322F"/>
-                </a:solidFill>
-                <a:latin typeface="Instrument Sans"/>
-                <a:ea typeface="Instrument Sans"/>
-                <a:cs typeface="Instrument Sans"/>
-                <a:sym typeface="Instrument Sans"/>
-              </a:rPr>
-              <a:t>freelance projects (Remote Labor Index)</a:t>
-            </a:r>
-          </a:p>
-        </p:txBody>
-      </p:sp>
-      <p:sp>
-        <p:nvSpPr>
-          <p:cNvPr id="5022" name="SimReal 5022"/>
-          <p:cNvSpPr txBox="1"/>
-          <p:nvPr/>
-        </p:nvSpPr>
-        <p:spPr>
-          <a:xfrm>
-            <a:off x="548640" y="3255264"/>
-            <a:ext cx="7498080" cy="329184"/>
+            <a:off x="548640" y="5120640"/>
+            <a:ext cx="11091672" cy="420624"/>
           </a:xfrm>
           <a:prstGeom prst="rect">
             <a:avLst/>
@@ -31336,7 +31304,7 @@
               <a:buNone/>
             </a:pPr>
             <a:r>
-              <a:rPr lang="en-US" sz="1600" b="0" i="0" u="none" strike="noStrike" cap="none">
+              <a:rPr lang="en-US" sz="2400" b="0" i="0" u="none" strike="noStrike" cap="none">
                 <a:solidFill>
                   <a:srgbClr val="111110"/>
                 </a:solidFill>
@@ -31345,10 +31313,10 @@
                 <a:cs typeface="Newsreader"/>
                 <a:sym typeface="Newsreader"/>
               </a:rPr>
-              <a:t>What keeps the loop turning: </a:t>
-            </a:r>
-            <a:r>
-              <a:rPr lang="en-US" sz="1600" b="0" i="0" u="none" strike="noStrike" cap="none">
+              <a:t>Sandboxes keep agents out of trouble. </a:t>
+            </a:r>
+            <a:r>
+              <a:rPr lang="en-US" sz="2400" b="0" i="0" u="none" strike="noStrike" cap="none">
                 <a:solidFill>
                   <a:srgbClr val="C2410C"/>
                 </a:solidFill>
@@ -31357,174 +31325,10 @@
                 <a:cs typeface="Newsreader"/>
                 <a:sym typeface="Newsreader"/>
               </a:rPr>
-              <a:t>personal agents</a:t>
-            </a:r>
-          </a:p>
-        </p:txBody>
-      </p:sp>
-      <p:sp>
-        <p:nvSpPr>
-          <p:cNvPr id="5023" name="SimReal 5023"/>
-          <p:cNvSpPr txBox="1"/>
-          <p:nvPr/>
-        </p:nvSpPr>
-        <p:spPr>
-          <a:xfrm>
-            <a:off x="8046720" y="3255264"/>
-            <a:ext cx="3593592" cy="329184"/>
-          </a:xfrm>
-          <a:prstGeom prst="rect">
-            <a:avLst/>
-          </a:prstGeom>
-          <a:noFill/>
-          <a:ln>
-            <a:noFill/>
-          </a:ln>
-        </p:spPr>
-        <p:txBody>
-          <a:bodyPr spcFirstLastPara="1" wrap="square" lIns="0" tIns="0" rIns="0" bIns="0" anchor="ctr" anchorCtr="0">
-            <a:noAutofit/>
-          </a:bodyPr>
-          <a:lstStyle/>
-          <a:p>
-            <a:pPr marL="0" marR="0" lvl="0" indent="0" algn="r" rtl="0">
-              <a:spcBef>
-                <a:spcPts val="0"/>
-              </a:spcBef>
-              <a:spcAft>
-                <a:spcPts val="0"/>
-              </a:spcAft>
-              <a:buNone/>
-            </a:pPr>
-            <a:r>
-              <a:rPr lang="en-US" sz="900" b="0" i="0" u="none" strike="noStrike" cap="none">
-                <a:solidFill>
-                  <a:srgbClr val="6E6C66"/>
-                </a:solidFill>
-                <a:latin typeface="Instrument Sans"/>
-                <a:ea typeface="Instrument Sans"/>
-                <a:cs typeface="Instrument Sans"/>
-                <a:sym typeface="Instrument Sans"/>
-              </a:rPr>
-              <a:t>Dark: proven in Xitadel  ·  Light: planned this round</a:t>
-            </a:r>
-          </a:p>
-        </p:txBody>
-      </p:sp>
-      <p:sp>
-        <p:nvSpPr>
-          <p:cNvPr id="5024" name="SimReal 5024"/>
-          <p:cNvSpPr/>
-          <p:nvPr/>
-        </p:nvSpPr>
-        <p:spPr>
-          <a:xfrm>
-            <a:off x="548640" y="3639312"/>
-            <a:ext cx="1998878" cy="1097280"/>
-          </a:xfrm>
-          <a:prstGeom prst="rect">
-            <a:avLst/>
-          </a:prstGeom>
-          <a:solidFill>
-            <a:srgbClr val="F2F1EC"/>
-          </a:solidFill>
-          <a:ln>
-            <a:noFill/>
-          </a:ln>
-        </p:spPr>
-        <p:txBody>
-          <a:bodyPr/>
-          <a:lstStyle/>
-          <a:p>
-            <a:endParaRPr/>
-          </a:p>
-        </p:txBody>
-      </p:sp>
-      <p:sp>
-        <p:nvSpPr>
-          <p:cNvPr id="5025" name="SimReal 5025"/>
-          <p:cNvSpPr txBox="1"/>
-          <p:nvPr/>
-        </p:nvSpPr>
-        <p:spPr>
-          <a:xfrm>
-            <a:off x="713232" y="3749040"/>
-            <a:ext cx="1724558" cy="182880"/>
-          </a:xfrm>
-          <a:prstGeom prst="rect">
-            <a:avLst/>
-          </a:prstGeom>
-          <a:noFill/>
-          <a:ln>
-            <a:noFill/>
-          </a:ln>
-        </p:spPr>
-        <p:txBody>
-          <a:bodyPr spcFirstLastPara="1" wrap="square" lIns="0" tIns="0" rIns="0" bIns="0" anchor="t" anchorCtr="0">
-            <a:noAutofit/>
-          </a:bodyPr>
-          <a:lstStyle/>
-          <a:p>
-            <a:pPr marL="0" marR="0" lvl="0" indent="0" algn="l" rtl="0">
-              <a:spcBef>
-                <a:spcPts val="0"/>
-              </a:spcBef>
-              <a:spcAft>
-                <a:spcPts val="0"/>
-              </a:spcAft>
-              <a:buNone/>
-            </a:pPr>
-            <a:r>
-              <a:rPr lang="en-US" sz="900" b="0" i="0" u="none" strike="noStrike" cap="none">
-                <a:solidFill>
-                  <a:srgbClr val="C2410C"/>
-                </a:solidFill>
-                <a:latin typeface="IBM Plex Mono"/>
-                <a:ea typeface="IBM Plex Mono"/>
-                <a:cs typeface="IBM Plex Mono"/>
-                <a:sym typeface="IBM Plex Mono"/>
-              </a:rPr>
-              <a:t>Planned</a:t>
-            </a:r>
-          </a:p>
-        </p:txBody>
-      </p:sp>
-      <p:sp>
-        <p:nvSpPr>
-          <p:cNvPr id="5026" name="SimReal 5026"/>
-          <p:cNvSpPr txBox="1"/>
-          <p:nvPr/>
-        </p:nvSpPr>
-        <p:spPr>
-          <a:xfrm>
-            <a:off x="713232" y="3968496"/>
-            <a:ext cx="1724558" cy="310896"/>
-          </a:xfrm>
-          <a:prstGeom prst="rect">
-            <a:avLst/>
-          </a:prstGeom>
-          <a:noFill/>
-          <a:ln>
-            <a:noFill/>
-          </a:ln>
-        </p:spPr>
-        <p:txBody>
-          <a:bodyPr spcFirstLastPara="1" wrap="square" lIns="0" tIns="0" rIns="0" bIns="0" anchor="t" anchorCtr="0">
-            <a:noAutofit/>
-          </a:bodyPr>
-          <a:lstStyle/>
-          <a:p>
-            <a:pPr marL="0" marR="0" lvl="0" indent="0" algn="l" rtl="0">
-              <a:spcBef>
-                <a:spcPts val="0"/>
-              </a:spcBef>
-              <a:spcAft>
-                <a:spcPts val="0"/>
-              </a:spcAft>
-              <a:buNone/>
-            </a:pPr>
-            <a:r>
-              <a:rPr lang="en-US" sz="1500" b="0" i="0" u="none" strike="noStrike" cap="none">
+              <a:t>We teach them to get it right</a:t>
+            </a:r>
+            <a:r>
+              <a:rPr lang="en-US" sz="2400" b="0" i="0" u="none" strike="noStrike" cap="none">
                 <a:solidFill>
                   <a:srgbClr val="111110"/>
                 </a:solidFill>
@@ -31533,1370 +31337,6 @@
                 <a:cs typeface="Newsreader"/>
                 <a:sym typeface="Newsreader"/>
               </a:rPr>
-              <a:t>Practice</a:t>
-            </a:r>
-          </a:p>
-        </p:txBody>
-      </p:sp>
-      <p:sp>
-        <p:nvSpPr>
-          <p:cNvPr id="5027" name="SimReal 5027"/>
-          <p:cNvSpPr txBox="1"/>
-          <p:nvPr/>
-        </p:nvSpPr>
-        <p:spPr>
-          <a:xfrm>
-            <a:off x="713232" y="4315968"/>
-            <a:ext cx="1724558" cy="365760"/>
-          </a:xfrm>
-          <a:prstGeom prst="rect">
-            <a:avLst/>
-          </a:prstGeom>
-          <a:noFill/>
-          <a:ln>
-            <a:noFill/>
-          </a:ln>
-        </p:spPr>
-        <p:txBody>
-          <a:bodyPr spcFirstLastPara="1" wrap="square" lIns="0" tIns="0" rIns="0" bIns="0" anchor="t" anchorCtr="0">
-            <a:noAutofit/>
-          </a:bodyPr>
-          <a:lstStyle/>
-          <a:p>
-            <a:pPr marL="0" marR="0" lvl="0" indent="0" algn="l" rtl="0">
-              <a:lnSpc>
-                <a:spcPct val="110000"/>
-              </a:lnSpc>
-              <a:spcBef>
-                <a:spcPts val="0"/>
-              </a:spcBef>
-              <a:spcAft>
-                <a:spcPts val="0"/>
-              </a:spcAft>
-              <a:buNone/>
-            </a:pPr>
-            <a:r>
-              <a:rPr lang="en-US" sz="950" b="0" i="0" u="none" strike="noStrike" cap="none">
-                <a:solidFill>
-                  <a:srgbClr val="33322F"/>
-                </a:solidFill>
-                <a:latin typeface="Instrument Sans"/>
-                <a:ea typeface="Instrument Sans"/>
-                <a:cs typeface="Instrument Sans"/>
-                <a:sym typeface="Instrument Sans"/>
-              </a:rPr>
-              <a:t>Trading and prediction first;</a:t>
-            </a:r>
-          </a:p>
-          <a:p>
-            <a:pPr marL="0" marR="0" lvl="0" indent="0" algn="l" rtl="0">
-              <a:lnSpc>
-                <a:spcPct val="110000"/>
-              </a:lnSpc>
-              <a:spcBef>
-                <a:spcPts val="0"/>
-              </a:spcBef>
-              <a:spcAft>
-                <a:spcPts val="0"/>
-              </a:spcAft>
-              <a:buNone/>
-            </a:pPr>
-            <a:r>
-              <a:rPr lang="en-US" sz="950" b="0" i="0" u="none" strike="noStrike" cap="none">
-                <a:solidFill>
-                  <a:srgbClr val="33322F"/>
-                </a:solidFill>
-                <a:latin typeface="Instrument Sans"/>
-                <a:ea typeface="Instrument Sans"/>
-                <a:cs typeface="Instrument Sans"/>
-                <a:sym typeface="Instrument Sans"/>
-              </a:rPr>
-              <a:t>held-out sets stay closed</a:t>
-            </a:r>
-          </a:p>
-        </p:txBody>
-      </p:sp>
-      <p:sp>
-        <p:nvSpPr>
-          <p:cNvPr id="5028" name="SimReal 5028"/>
-          <p:cNvSpPr txBox="1"/>
-          <p:nvPr/>
-        </p:nvSpPr>
-        <p:spPr>
-          <a:xfrm>
-            <a:off x="2547518" y="3639312"/>
-            <a:ext cx="274320" cy="1097280"/>
-          </a:xfrm>
-          <a:prstGeom prst="rect">
-            <a:avLst/>
-          </a:prstGeom>
-          <a:noFill/>
-          <a:ln>
-            <a:noFill/>
-          </a:ln>
-        </p:spPr>
-        <p:txBody>
-          <a:bodyPr spcFirstLastPara="1" wrap="square" lIns="0" tIns="0" rIns="0" bIns="0" anchor="ctr" anchorCtr="0">
-            <a:noAutofit/>
-          </a:bodyPr>
-          <a:lstStyle/>
-          <a:p>
-            <a:pPr marL="0" marR="0" lvl="0" indent="0" algn="ctr" rtl="0">
-              <a:spcBef>
-                <a:spcPts val="0"/>
-              </a:spcBef>
-              <a:spcAft>
-                <a:spcPts val="0"/>
-              </a:spcAft>
-              <a:buNone/>
-            </a:pPr>
-            <a:r>
-              <a:rPr lang="en-US" sz="1200" b="0" i="0" u="none" strike="noStrike" cap="none">
-                <a:solidFill>
-                  <a:srgbClr val="6E6C66"/>
-                </a:solidFill>
-                <a:latin typeface="Instrument Sans"/>
-                <a:ea typeface="Instrument Sans"/>
-                <a:cs typeface="Instrument Sans"/>
-                <a:sym typeface="Instrument Sans"/>
-              </a:rPr>
-              <a:t>→</a:t>
-            </a:r>
-          </a:p>
-        </p:txBody>
-      </p:sp>
-      <p:sp>
-        <p:nvSpPr>
-          <p:cNvPr id="5029" name="SimReal 5029"/>
-          <p:cNvSpPr/>
-          <p:nvPr/>
-        </p:nvSpPr>
-        <p:spPr>
-          <a:xfrm>
-            <a:off x="2821838" y="3639312"/>
-            <a:ext cx="1998878" cy="1097280"/>
-          </a:xfrm>
-          <a:prstGeom prst="rect">
-            <a:avLst/>
-          </a:prstGeom>
-          <a:solidFill>
-            <a:srgbClr val="111110"/>
-          </a:solidFill>
-          <a:ln>
-            <a:noFill/>
-          </a:ln>
-        </p:spPr>
-        <p:txBody>
-          <a:bodyPr/>
-          <a:lstStyle/>
-          <a:p>
-            <a:endParaRPr/>
-          </a:p>
-        </p:txBody>
-      </p:sp>
-      <p:sp>
-        <p:nvSpPr>
-          <p:cNvPr id="5030" name="SimReal 5030"/>
-          <p:cNvSpPr txBox="1"/>
-          <p:nvPr/>
-        </p:nvSpPr>
-        <p:spPr>
-          <a:xfrm>
-            <a:off x="2986430" y="3749040"/>
-            <a:ext cx="1724558" cy="182880"/>
-          </a:xfrm>
-          <a:prstGeom prst="rect">
-            <a:avLst/>
-          </a:prstGeom>
-          <a:noFill/>
-          <a:ln>
-            <a:noFill/>
-          </a:ln>
-        </p:spPr>
-        <p:txBody>
-          <a:bodyPr spcFirstLastPara="1" wrap="square" lIns="0" tIns="0" rIns="0" bIns="0" anchor="t" anchorCtr="0">
-            <a:noAutofit/>
-          </a:bodyPr>
-          <a:lstStyle/>
-          <a:p>
-            <a:pPr marL="0" marR="0" lvl="0" indent="0" algn="l" rtl="0">
-              <a:spcBef>
-                <a:spcPts val="0"/>
-              </a:spcBef>
-              <a:spcAft>
-                <a:spcPts val="0"/>
-              </a:spcAft>
-              <a:buNone/>
-            </a:pPr>
-            <a:r>
-              <a:rPr lang="en-US" sz="900" b="0" i="0" u="none" strike="noStrike" cap="none">
-                <a:solidFill>
-                  <a:srgbClr val="E27A3F"/>
-                </a:solidFill>
-                <a:latin typeface="IBM Plex Mono"/>
-                <a:ea typeface="IBM Plex Mono"/>
-                <a:cs typeface="IBM Plex Mono"/>
-                <a:sym typeface="IBM Plex Mono"/>
-              </a:rPr>
-              <a:t>Proven</a:t>
-            </a:r>
-          </a:p>
-        </p:txBody>
-      </p:sp>
-      <p:sp>
-        <p:nvSpPr>
-          <p:cNvPr id="5031" name="SimReal 5031"/>
-          <p:cNvSpPr txBox="1"/>
-          <p:nvPr/>
-        </p:nvSpPr>
-        <p:spPr>
-          <a:xfrm>
-            <a:off x="2986430" y="3968496"/>
-            <a:ext cx="1724558" cy="310896"/>
-          </a:xfrm>
-          <a:prstGeom prst="rect">
-            <a:avLst/>
-          </a:prstGeom>
-          <a:noFill/>
-          <a:ln>
-            <a:noFill/>
-          </a:ln>
-        </p:spPr>
-        <p:txBody>
-          <a:bodyPr spcFirstLastPara="1" wrap="square" lIns="0" tIns="0" rIns="0" bIns="0" anchor="t" anchorCtr="0">
-            <a:noAutofit/>
-          </a:bodyPr>
-          <a:lstStyle/>
-          <a:p>
-            <a:pPr marL="0" marR="0" lvl="0" indent="0" algn="l" rtl="0">
-              <a:spcBef>
-                <a:spcPts val="0"/>
-              </a:spcBef>
-              <a:spcAft>
-                <a:spcPts val="0"/>
-              </a:spcAft>
-              <a:buNone/>
-            </a:pPr>
-            <a:r>
-              <a:rPr lang="en-US" sz="1500" b="0" i="0" u="none" strike="noStrike" cap="none">
-                <a:solidFill>
-                  <a:srgbClr val="FAF9F6"/>
-                </a:solidFill>
-                <a:latin typeface="Newsreader"/>
-                <a:ea typeface="Newsreader"/>
-                <a:cs typeface="Newsreader"/>
-                <a:sym typeface="Newsreader"/>
-              </a:rPr>
-              <a:t>Outcomes settle</a:t>
-            </a:r>
-          </a:p>
-        </p:txBody>
-      </p:sp>
-      <p:sp>
-        <p:nvSpPr>
-          <p:cNvPr id="5032" name="SimReal 5032"/>
-          <p:cNvSpPr txBox="1"/>
-          <p:nvPr/>
-        </p:nvSpPr>
-        <p:spPr>
-          <a:xfrm>
-            <a:off x="2986430" y="4315968"/>
-            <a:ext cx="1724558" cy="365760"/>
-          </a:xfrm>
-          <a:prstGeom prst="rect">
-            <a:avLst/>
-          </a:prstGeom>
-          <a:noFill/>
-          <a:ln>
-            <a:noFill/>
-          </a:ln>
-        </p:spPr>
-        <p:txBody>
-          <a:bodyPr spcFirstLastPara="1" wrap="square" lIns="0" tIns="0" rIns="0" bIns="0" anchor="t" anchorCtr="0">
-            <a:noAutofit/>
-          </a:bodyPr>
-          <a:lstStyle/>
-          <a:p>
-            <a:pPr marL="0" marR="0" lvl="0" indent="0" algn="l" rtl="0">
-              <a:lnSpc>
-                <a:spcPct val="110000"/>
-              </a:lnSpc>
-              <a:spcBef>
-                <a:spcPts val="0"/>
-              </a:spcBef>
-              <a:spcAft>
-                <a:spcPts val="0"/>
-              </a:spcAft>
-              <a:buNone/>
-            </a:pPr>
-            <a:r>
-              <a:rPr lang="en-US" sz="950" b="0" i="0" u="none" strike="noStrike" cap="none">
-                <a:solidFill>
-                  <a:srgbClr val="C4C0B7"/>
-                </a:solidFill>
-                <a:latin typeface="Instrument Sans"/>
-                <a:ea typeface="Instrument Sans"/>
-                <a:cs typeface="Instrument Sans"/>
-                <a:sym typeface="Instrument Sans"/>
-              </a:rPr>
-              <a:t>The market settles every</a:t>
-            </a:r>
-          </a:p>
-          <a:p>
-            <a:pPr marL="0" marR="0" lvl="0" indent="0" algn="l" rtl="0">
-              <a:lnSpc>
-                <a:spcPct val="110000"/>
-              </a:lnSpc>
-              <a:spcBef>
-                <a:spcPts val="0"/>
-              </a:spcBef>
-              <a:spcAft>
-                <a:spcPts val="0"/>
-              </a:spcAft>
-              <a:buNone/>
-            </a:pPr>
-            <a:r>
-              <a:rPr lang="en-US" sz="950" b="0" i="0" u="none" strike="noStrike" cap="none">
-                <a:solidFill>
-                  <a:srgbClr val="C4C0B7"/>
-                </a:solidFill>
-                <a:latin typeface="Instrument Sans"/>
-                <a:ea typeface="Instrument Sans"/>
-                <a:cs typeface="Instrument Sans"/>
-                <a:sym typeface="Instrument Sans"/>
-              </a:rPr>
-              <a:t>trade; trajectories kept</a:t>
-            </a:r>
-          </a:p>
-        </p:txBody>
-      </p:sp>
-      <p:sp>
-        <p:nvSpPr>
-          <p:cNvPr id="5033" name="SimReal 5033"/>
-          <p:cNvSpPr txBox="1"/>
-          <p:nvPr/>
-        </p:nvSpPr>
-        <p:spPr>
-          <a:xfrm>
-            <a:off x="4820717" y="3639312"/>
-            <a:ext cx="274320" cy="1097280"/>
-          </a:xfrm>
-          <a:prstGeom prst="rect">
-            <a:avLst/>
-          </a:prstGeom>
-          <a:noFill/>
-          <a:ln>
-            <a:noFill/>
-          </a:ln>
-        </p:spPr>
-        <p:txBody>
-          <a:bodyPr spcFirstLastPara="1" wrap="square" lIns="0" tIns="0" rIns="0" bIns="0" anchor="ctr" anchorCtr="0">
-            <a:noAutofit/>
-          </a:bodyPr>
-          <a:lstStyle/>
-          <a:p>
-            <a:pPr marL="0" marR="0" lvl="0" indent="0" algn="ctr" rtl="0">
-              <a:spcBef>
-                <a:spcPts val="0"/>
-              </a:spcBef>
-              <a:spcAft>
-                <a:spcPts val="0"/>
-              </a:spcAft>
-              <a:buNone/>
-            </a:pPr>
-            <a:r>
-              <a:rPr lang="en-US" sz="1200" b="0" i="0" u="none" strike="noStrike" cap="none">
-                <a:solidFill>
-                  <a:srgbClr val="6E6C66"/>
-                </a:solidFill>
-                <a:latin typeface="Instrument Sans"/>
-                <a:ea typeface="Instrument Sans"/>
-                <a:cs typeface="Instrument Sans"/>
-                <a:sym typeface="Instrument Sans"/>
-              </a:rPr>
-              <a:t>→</a:t>
-            </a:r>
-          </a:p>
-        </p:txBody>
-      </p:sp>
-      <p:sp>
-        <p:nvSpPr>
-          <p:cNvPr id="5034" name="SimReal 5034"/>
-          <p:cNvSpPr/>
-          <p:nvPr/>
-        </p:nvSpPr>
-        <p:spPr>
-          <a:xfrm>
-            <a:off x="5095037" y="3639312"/>
-            <a:ext cx="1998878" cy="1097280"/>
-          </a:xfrm>
-          <a:prstGeom prst="rect">
-            <a:avLst/>
-          </a:prstGeom>
-          <a:solidFill>
-            <a:srgbClr val="111110"/>
-          </a:solidFill>
-          <a:ln>
-            <a:noFill/>
-          </a:ln>
-        </p:spPr>
-        <p:txBody>
-          <a:bodyPr/>
-          <a:lstStyle/>
-          <a:p>
-            <a:endParaRPr/>
-          </a:p>
-        </p:txBody>
-      </p:sp>
-      <p:sp>
-        <p:nvSpPr>
-          <p:cNvPr id="5035" name="SimReal 5035"/>
-          <p:cNvSpPr txBox="1"/>
-          <p:nvPr/>
-        </p:nvSpPr>
-        <p:spPr>
-          <a:xfrm>
-            <a:off x="5259629" y="3749040"/>
-            <a:ext cx="1724558" cy="182880"/>
-          </a:xfrm>
-          <a:prstGeom prst="rect">
-            <a:avLst/>
-          </a:prstGeom>
-          <a:noFill/>
-          <a:ln>
-            <a:noFill/>
-          </a:ln>
-        </p:spPr>
-        <p:txBody>
-          <a:bodyPr spcFirstLastPara="1" wrap="square" lIns="0" tIns="0" rIns="0" bIns="0" anchor="t" anchorCtr="0">
-            <a:noAutofit/>
-          </a:bodyPr>
-          <a:lstStyle/>
-          <a:p>
-            <a:pPr marL="0" marR="0" lvl="0" indent="0" algn="l" rtl="0">
-              <a:spcBef>
-                <a:spcPts val="0"/>
-              </a:spcBef>
-              <a:spcAft>
-                <a:spcPts val="0"/>
-              </a:spcAft>
-              <a:buNone/>
-            </a:pPr>
-            <a:r>
-              <a:rPr lang="en-US" sz="900" b="0" i="0" u="none" strike="noStrike" cap="none">
-                <a:solidFill>
-                  <a:srgbClr val="E27A3F"/>
-                </a:solidFill>
-                <a:latin typeface="IBM Plex Mono"/>
-                <a:ea typeface="IBM Plex Mono"/>
-                <a:cs typeface="IBM Plex Mono"/>
-                <a:sym typeface="IBM Plex Mono"/>
-              </a:rPr>
-              <a:t>Proven</a:t>
-            </a:r>
-          </a:p>
-        </p:txBody>
-      </p:sp>
-      <p:sp>
-        <p:nvSpPr>
-          <p:cNvPr id="5036" name="SimReal 5036"/>
-          <p:cNvSpPr txBox="1"/>
-          <p:nvPr/>
-        </p:nvSpPr>
-        <p:spPr>
-          <a:xfrm>
-            <a:off x="5259629" y="3968496"/>
-            <a:ext cx="1724558" cy="310896"/>
-          </a:xfrm>
-          <a:prstGeom prst="rect">
-            <a:avLst/>
-          </a:prstGeom>
-          <a:noFill/>
-          <a:ln>
-            <a:noFill/>
-          </a:ln>
-        </p:spPr>
-        <p:txBody>
-          <a:bodyPr spcFirstLastPara="1" wrap="square" lIns="0" tIns="0" rIns="0" bIns="0" anchor="t" anchorCtr="0">
-            <a:noAutofit/>
-          </a:bodyPr>
-          <a:lstStyle/>
-          <a:p>
-            <a:pPr marL="0" marR="0" lvl="0" indent="0" algn="l" rtl="0">
-              <a:spcBef>
-                <a:spcPts val="0"/>
-              </a:spcBef>
-              <a:spcAft>
-                <a:spcPts val="0"/>
-              </a:spcAft>
-              <a:buNone/>
-            </a:pPr>
-            <a:r>
-              <a:rPr lang="en-US" sz="1500" b="0" i="0" u="none" strike="noStrike" cap="none">
-                <a:solidFill>
-                  <a:srgbClr val="FAF9F6"/>
-                </a:solidFill>
-                <a:latin typeface="Newsreader"/>
-                <a:ea typeface="Newsreader"/>
-                <a:cs typeface="Newsreader"/>
-                <a:sym typeface="Newsreader"/>
-              </a:rPr>
-              <a:t>Agents improve</a:t>
-            </a:r>
-          </a:p>
-        </p:txBody>
-      </p:sp>
-      <p:sp>
-        <p:nvSpPr>
-          <p:cNvPr id="5037" name="SimReal 5037"/>
-          <p:cNvSpPr txBox="1"/>
-          <p:nvPr/>
-        </p:nvSpPr>
-        <p:spPr>
-          <a:xfrm>
-            <a:off x="5259629" y="4315968"/>
-            <a:ext cx="1724558" cy="365760"/>
-          </a:xfrm>
-          <a:prstGeom prst="rect">
-            <a:avLst/>
-          </a:prstGeom>
-          <a:noFill/>
-          <a:ln>
-            <a:noFill/>
-          </a:ln>
-        </p:spPr>
-        <p:txBody>
-          <a:bodyPr spcFirstLastPara="1" wrap="square" lIns="0" tIns="0" rIns="0" bIns="0" anchor="t" anchorCtr="0">
-            <a:noAutofit/>
-          </a:bodyPr>
-          <a:lstStyle/>
-          <a:p>
-            <a:pPr marL="0" marR="0" lvl="0" indent="0" algn="l" rtl="0">
-              <a:lnSpc>
-                <a:spcPct val="110000"/>
-              </a:lnSpc>
-              <a:spcBef>
-                <a:spcPts val="0"/>
-              </a:spcBef>
-              <a:spcAft>
-                <a:spcPts val="0"/>
-              </a:spcAft>
-              <a:buNone/>
-            </a:pPr>
-            <a:r>
-              <a:rPr lang="en-US" sz="950" b="0" i="0" u="none" strike="noStrike" cap="none">
-                <a:solidFill>
-                  <a:srgbClr val="C4C0B7"/>
-                </a:solidFill>
-                <a:latin typeface="Instrument Sans"/>
-                <a:ea typeface="Instrument Sans"/>
-                <a:cs typeface="Instrument Sans"/>
-                <a:sym typeface="Instrument Sans"/>
-              </a:rPr>
-              <a:t>After training, Qwen3.8-27B</a:t>
-            </a:r>
-          </a:p>
-          <a:p>
-            <a:pPr marL="0" marR="0" lvl="0" indent="0" algn="l" rtl="0">
-              <a:lnSpc>
-                <a:spcPct val="110000"/>
-              </a:lnSpc>
-              <a:spcBef>
-                <a:spcPts val="0"/>
-              </a:spcBef>
-              <a:spcAft>
-                <a:spcPts val="0"/>
-              </a:spcAft>
-              <a:buNone/>
-            </a:pPr>
-            <a:r>
-              <a:rPr lang="en-US" sz="950" b="0" i="0" u="none" strike="noStrike" cap="none">
-                <a:solidFill>
-                  <a:srgbClr val="C4C0B7"/>
-                </a:solidFill>
-                <a:latin typeface="Instrument Sans"/>
-                <a:ea typeface="Instrument Sans"/>
-                <a:cs typeface="Instrument Sans"/>
-                <a:sym typeface="Instrument Sans"/>
-              </a:rPr>
-              <a:t>traded up to 12% better</a:t>
-            </a:r>
-          </a:p>
-        </p:txBody>
-      </p:sp>
-      <p:sp>
-        <p:nvSpPr>
-          <p:cNvPr id="5038" name="SimReal 5038"/>
-          <p:cNvSpPr txBox="1"/>
-          <p:nvPr/>
-        </p:nvSpPr>
-        <p:spPr>
-          <a:xfrm>
-            <a:off x="7093915" y="3639312"/>
-            <a:ext cx="274320" cy="1097280"/>
-          </a:xfrm>
-          <a:prstGeom prst="rect">
-            <a:avLst/>
-          </a:prstGeom>
-          <a:noFill/>
-          <a:ln>
-            <a:noFill/>
-          </a:ln>
-        </p:spPr>
-        <p:txBody>
-          <a:bodyPr spcFirstLastPara="1" wrap="square" lIns="0" tIns="0" rIns="0" bIns="0" anchor="ctr" anchorCtr="0">
-            <a:noAutofit/>
-          </a:bodyPr>
-          <a:lstStyle/>
-          <a:p>
-            <a:pPr marL="0" marR="0" lvl="0" indent="0" algn="ctr" rtl="0">
-              <a:spcBef>
-                <a:spcPts val="0"/>
-              </a:spcBef>
-              <a:spcAft>
-                <a:spcPts val="0"/>
-              </a:spcAft>
-              <a:buNone/>
-            </a:pPr>
-            <a:r>
-              <a:rPr lang="en-US" sz="1200" b="0" i="0" u="none" strike="noStrike" cap="none">
-                <a:solidFill>
-                  <a:srgbClr val="6E6C66"/>
-                </a:solidFill>
-                <a:latin typeface="Instrument Sans"/>
-                <a:ea typeface="Instrument Sans"/>
-                <a:cs typeface="Instrument Sans"/>
-                <a:sym typeface="Instrument Sans"/>
-              </a:rPr>
-              <a:t>→</a:t>
-            </a:r>
-          </a:p>
-        </p:txBody>
-      </p:sp>
-      <p:sp>
-        <p:nvSpPr>
-          <p:cNvPr id="5039" name="SimReal 5039"/>
-          <p:cNvSpPr/>
-          <p:nvPr/>
-        </p:nvSpPr>
-        <p:spPr>
-          <a:xfrm>
-            <a:off x="7368235" y="3639312"/>
-            <a:ext cx="1998878" cy="1097280"/>
-          </a:xfrm>
-          <a:prstGeom prst="rect">
-            <a:avLst/>
-          </a:prstGeom>
-          <a:solidFill>
-            <a:srgbClr val="F2F1EC"/>
-          </a:solidFill>
-          <a:ln>
-            <a:noFill/>
-          </a:ln>
-        </p:spPr>
-        <p:txBody>
-          <a:bodyPr/>
-          <a:lstStyle/>
-          <a:p>
-            <a:endParaRPr/>
-          </a:p>
-        </p:txBody>
-      </p:sp>
-      <p:sp>
-        <p:nvSpPr>
-          <p:cNvPr id="5040" name="SimReal 5040"/>
-          <p:cNvSpPr txBox="1"/>
-          <p:nvPr/>
-        </p:nvSpPr>
-        <p:spPr>
-          <a:xfrm>
-            <a:off x="7532827" y="3749040"/>
-            <a:ext cx="1724558" cy="182880"/>
-          </a:xfrm>
-          <a:prstGeom prst="rect">
-            <a:avLst/>
-          </a:prstGeom>
-          <a:noFill/>
-          <a:ln>
-            <a:noFill/>
-          </a:ln>
-        </p:spPr>
-        <p:txBody>
-          <a:bodyPr spcFirstLastPara="1" wrap="square" lIns="0" tIns="0" rIns="0" bIns="0" anchor="t" anchorCtr="0">
-            <a:noAutofit/>
-          </a:bodyPr>
-          <a:lstStyle/>
-          <a:p>
-            <a:pPr marL="0" marR="0" lvl="0" indent="0" algn="l" rtl="0">
-              <a:spcBef>
-                <a:spcPts val="0"/>
-              </a:spcBef>
-              <a:spcAft>
-                <a:spcPts val="0"/>
-              </a:spcAft>
-              <a:buNone/>
-            </a:pPr>
-            <a:r>
-              <a:rPr lang="en-US" sz="900" b="0" i="0" u="none" strike="noStrike" cap="none">
-                <a:solidFill>
-                  <a:srgbClr val="C2410C"/>
-                </a:solidFill>
-                <a:latin typeface="IBM Plex Mono"/>
-                <a:ea typeface="IBM Plex Mono"/>
-                <a:cs typeface="IBM Plex Mono"/>
-                <a:sym typeface="IBM Plex Mono"/>
-              </a:rPr>
-              <a:t>Planned</a:t>
-            </a:r>
-          </a:p>
-        </p:txBody>
-      </p:sp>
-      <p:sp>
-        <p:nvSpPr>
-          <p:cNvPr id="5041" name="SimReal 5041"/>
-          <p:cNvSpPr txBox="1"/>
-          <p:nvPr/>
-        </p:nvSpPr>
-        <p:spPr>
-          <a:xfrm>
-            <a:off x="7532827" y="3968496"/>
-            <a:ext cx="1724558" cy="310896"/>
-          </a:xfrm>
-          <a:prstGeom prst="rect">
-            <a:avLst/>
-          </a:prstGeom>
-          <a:noFill/>
-          <a:ln>
-            <a:noFill/>
-          </a:ln>
-        </p:spPr>
-        <p:txBody>
-          <a:bodyPr spcFirstLastPara="1" wrap="square" lIns="0" tIns="0" rIns="0" bIns="0" anchor="t" anchorCtr="0">
-            <a:noAutofit/>
-          </a:bodyPr>
-          <a:lstStyle/>
-          <a:p>
-            <a:pPr marL="0" marR="0" lvl="0" indent="0" algn="l" rtl="0">
-              <a:spcBef>
-                <a:spcPts val="0"/>
-              </a:spcBef>
-              <a:spcAft>
-                <a:spcPts val="0"/>
-              </a:spcAft>
-              <a:buNone/>
-            </a:pPr>
-            <a:r>
-              <a:rPr lang="en-US" sz="1500" b="0" i="0" u="none" strike="noStrike" cap="none">
-                <a:solidFill>
-                  <a:srgbClr val="111110"/>
-                </a:solidFill>
-                <a:latin typeface="Newsreader"/>
-                <a:ea typeface="Newsreader"/>
-                <a:cs typeface="Newsreader"/>
-                <a:sym typeface="Newsreader"/>
-              </a:rPr>
-              <a:t>Worlds get real</a:t>
-            </a:r>
-          </a:p>
-        </p:txBody>
-      </p:sp>
-      <p:sp>
-        <p:nvSpPr>
-          <p:cNvPr id="5042" name="SimReal 5042"/>
-          <p:cNvSpPr txBox="1"/>
-          <p:nvPr/>
-        </p:nvSpPr>
-        <p:spPr>
-          <a:xfrm>
-            <a:off x="7532827" y="4315968"/>
-            <a:ext cx="1724558" cy="365760"/>
-          </a:xfrm>
-          <a:prstGeom prst="rect">
-            <a:avLst/>
-          </a:prstGeom>
-          <a:noFill/>
-          <a:ln>
-            <a:noFill/>
-          </a:ln>
-        </p:spPr>
-        <p:txBody>
-          <a:bodyPr spcFirstLastPara="1" wrap="square" lIns="0" tIns="0" rIns="0" bIns="0" anchor="t" anchorCtr="0">
-            <a:noAutofit/>
-          </a:bodyPr>
-          <a:lstStyle/>
-          <a:p>
-            <a:pPr marL="0" marR="0" lvl="0" indent="0" algn="l" rtl="0">
-              <a:lnSpc>
-                <a:spcPct val="110000"/>
-              </a:lnSpc>
-              <a:spcBef>
-                <a:spcPts val="0"/>
-              </a:spcBef>
-              <a:spcAft>
-                <a:spcPts val="0"/>
-              </a:spcAft>
-              <a:buNone/>
-            </a:pPr>
-            <a:r>
-              <a:rPr lang="en-US" sz="950" b="0" i="0" u="none" strike="noStrike" cap="none">
-                <a:solidFill>
-                  <a:srgbClr val="33322F"/>
-                </a:solidFill>
-                <a:latin typeface="Instrument Sans"/>
-                <a:ea typeface="Instrument Sans"/>
-                <a:cs typeface="Instrument Sans"/>
-                <a:sym typeface="Instrument Sans"/>
-              </a:rPr>
-              <a:t>Exploits get patched;</a:t>
-            </a:r>
-          </a:p>
-          <a:p>
-            <a:pPr marL="0" marR="0" lvl="0" indent="0" algn="l" rtl="0">
-              <a:lnSpc>
-                <a:spcPct val="110000"/>
-              </a:lnSpc>
-              <a:spcBef>
-                <a:spcPts val="0"/>
-              </a:spcBef>
-              <a:spcAft>
-                <a:spcPts val="0"/>
-              </a:spcAft>
-              <a:buNone/>
-            </a:pPr>
-            <a:r>
-              <a:rPr lang="en-US" sz="950" b="0" i="0" u="none" strike="noStrike" cap="none">
-                <a:solidFill>
-                  <a:srgbClr val="33322F"/>
-                </a:solidFill>
-                <a:latin typeface="Instrument Sans"/>
-                <a:ea typeface="Instrument Sans"/>
-                <a:cs typeface="Instrument Sans"/>
-                <a:sym typeface="Instrument Sans"/>
-              </a:rPr>
-              <a:t>failures become new tasks</a:t>
-            </a:r>
-          </a:p>
-        </p:txBody>
-      </p:sp>
-      <p:sp>
-        <p:nvSpPr>
-          <p:cNvPr id="5043" name="SimReal 5043"/>
-          <p:cNvSpPr txBox="1"/>
-          <p:nvPr/>
-        </p:nvSpPr>
-        <p:spPr>
-          <a:xfrm>
-            <a:off x="9367114" y="3639312"/>
-            <a:ext cx="274320" cy="1097280"/>
-          </a:xfrm>
-          <a:prstGeom prst="rect">
-            <a:avLst/>
-          </a:prstGeom>
-          <a:noFill/>
-          <a:ln>
-            <a:noFill/>
-          </a:ln>
-        </p:spPr>
-        <p:txBody>
-          <a:bodyPr spcFirstLastPara="1" wrap="square" lIns="0" tIns="0" rIns="0" bIns="0" anchor="ctr" anchorCtr="0">
-            <a:noAutofit/>
-          </a:bodyPr>
-          <a:lstStyle/>
-          <a:p>
-            <a:pPr marL="0" marR="0" lvl="0" indent="0" algn="ctr" rtl="0">
-              <a:spcBef>
-                <a:spcPts val="0"/>
-              </a:spcBef>
-              <a:spcAft>
-                <a:spcPts val="0"/>
-              </a:spcAft>
-              <a:buNone/>
-            </a:pPr>
-            <a:r>
-              <a:rPr lang="en-US" sz="1200" b="0" i="0" u="none" strike="noStrike" cap="none">
-                <a:solidFill>
-                  <a:srgbClr val="6E6C66"/>
-                </a:solidFill>
-                <a:latin typeface="Instrument Sans"/>
-                <a:ea typeface="Instrument Sans"/>
-                <a:cs typeface="Instrument Sans"/>
-                <a:sym typeface="Instrument Sans"/>
-              </a:rPr>
-              <a:t>→</a:t>
-            </a:r>
-          </a:p>
-        </p:txBody>
-      </p:sp>
-      <p:sp>
-        <p:nvSpPr>
-          <p:cNvPr id="5044" name="SimReal 5044"/>
-          <p:cNvSpPr/>
-          <p:nvPr/>
-        </p:nvSpPr>
-        <p:spPr>
-          <a:xfrm>
-            <a:off x="9641434" y="3639312"/>
-            <a:ext cx="1998878" cy="1097280"/>
-          </a:xfrm>
-          <a:prstGeom prst="rect">
-            <a:avLst/>
-          </a:prstGeom>
-          <a:solidFill>
-            <a:srgbClr val="F2F1EC"/>
-          </a:solidFill>
-          <a:ln>
-            <a:noFill/>
-          </a:ln>
-        </p:spPr>
-        <p:txBody>
-          <a:bodyPr/>
-          <a:lstStyle/>
-          <a:p>
-            <a:endParaRPr/>
-          </a:p>
-        </p:txBody>
-      </p:sp>
-      <p:sp>
-        <p:nvSpPr>
-          <p:cNvPr id="5045" name="SimReal 5045"/>
-          <p:cNvSpPr txBox="1"/>
-          <p:nvPr/>
-        </p:nvSpPr>
-        <p:spPr>
-          <a:xfrm>
-            <a:off x="9806026" y="3749040"/>
-            <a:ext cx="1724558" cy="182880"/>
-          </a:xfrm>
-          <a:prstGeom prst="rect">
-            <a:avLst/>
-          </a:prstGeom>
-          <a:noFill/>
-          <a:ln>
-            <a:noFill/>
-          </a:ln>
-        </p:spPr>
-        <p:txBody>
-          <a:bodyPr spcFirstLastPara="1" wrap="square" lIns="0" tIns="0" rIns="0" bIns="0" anchor="t" anchorCtr="0">
-            <a:noAutofit/>
-          </a:bodyPr>
-          <a:lstStyle/>
-          <a:p>
-            <a:pPr marL="0" marR="0" lvl="0" indent="0" algn="l" rtl="0">
-              <a:spcBef>
-                <a:spcPts val="0"/>
-              </a:spcBef>
-              <a:spcAft>
-                <a:spcPts val="0"/>
-              </a:spcAft>
-              <a:buNone/>
-            </a:pPr>
-            <a:r>
-              <a:rPr lang="en-US" sz="900" b="0" i="0" u="none" strike="noStrike" cap="none">
-                <a:solidFill>
-                  <a:srgbClr val="C2410C"/>
-                </a:solidFill>
-                <a:latin typeface="IBM Plex Mono"/>
-                <a:ea typeface="IBM Plex Mono"/>
-                <a:cs typeface="IBM Plex Mono"/>
-                <a:sym typeface="IBM Plex Mono"/>
-              </a:rPr>
-              <a:t>Planned</a:t>
-            </a:r>
-          </a:p>
-        </p:txBody>
-      </p:sp>
-      <p:sp>
-        <p:nvSpPr>
-          <p:cNvPr id="5046" name="SimReal 5046"/>
-          <p:cNvSpPr txBox="1"/>
-          <p:nvPr/>
-        </p:nvSpPr>
-        <p:spPr>
-          <a:xfrm>
-            <a:off x="9806026" y="3968496"/>
-            <a:ext cx="1724558" cy="310896"/>
-          </a:xfrm>
-          <a:prstGeom prst="rect">
-            <a:avLst/>
-          </a:prstGeom>
-          <a:noFill/>
-          <a:ln>
-            <a:noFill/>
-          </a:ln>
-        </p:spPr>
-        <p:txBody>
-          <a:bodyPr spcFirstLastPara="1" wrap="square" lIns="0" tIns="0" rIns="0" bIns="0" anchor="t" anchorCtr="0">
-            <a:noAutofit/>
-          </a:bodyPr>
-          <a:lstStyle/>
-          <a:p>
-            <a:pPr marL="0" marR="0" lvl="0" indent="0" algn="l" rtl="0">
-              <a:spcBef>
-                <a:spcPts val="0"/>
-              </a:spcBef>
-              <a:spcAft>
-                <a:spcPts val="0"/>
-              </a:spcAft>
-              <a:buNone/>
-            </a:pPr>
-            <a:r>
-              <a:rPr lang="en-US" sz="1500" b="0" i="0" u="none" strike="noStrike" cap="none">
-                <a:solidFill>
-                  <a:srgbClr val="111110"/>
-                </a:solidFill>
-                <a:latin typeface="Newsreader"/>
-                <a:ea typeface="Newsreader"/>
-                <a:cs typeface="Newsreader"/>
-                <a:sym typeface="Newsreader"/>
-              </a:rPr>
-              <a:t>Data to labs</a:t>
-            </a:r>
-          </a:p>
-        </p:txBody>
-      </p:sp>
-      <p:sp>
-        <p:nvSpPr>
-          <p:cNvPr id="5047" name="SimReal 5047"/>
-          <p:cNvSpPr txBox="1"/>
-          <p:nvPr/>
-        </p:nvSpPr>
-        <p:spPr>
-          <a:xfrm>
-            <a:off x="9806026" y="4315968"/>
-            <a:ext cx="1724558" cy="365760"/>
-          </a:xfrm>
-          <a:prstGeom prst="rect">
-            <a:avLst/>
-          </a:prstGeom>
-          <a:noFill/>
-          <a:ln>
-            <a:noFill/>
-          </a:ln>
-        </p:spPr>
-        <p:txBody>
-          <a:bodyPr spcFirstLastPara="1" wrap="square" lIns="0" tIns="0" rIns="0" bIns="0" anchor="t" anchorCtr="0">
-            <a:noAutofit/>
-          </a:bodyPr>
-          <a:lstStyle/>
-          <a:p>
-            <a:pPr marL="0" marR="0" lvl="0" indent="0" algn="l" rtl="0">
-              <a:lnSpc>
-                <a:spcPct val="110000"/>
-              </a:lnSpc>
-              <a:spcBef>
-                <a:spcPts val="0"/>
-              </a:spcBef>
-              <a:spcAft>
-                <a:spcPts val="0"/>
-              </a:spcAft>
-              <a:buNone/>
-            </a:pPr>
-            <a:r>
-              <a:rPr lang="en-US" sz="950" b="0" i="0" u="none" strike="noStrike" cap="none">
-                <a:solidFill>
-                  <a:srgbClr val="33322F"/>
-                </a:solidFill>
-                <a:latin typeface="Instrument Sans"/>
-                <a:ea typeface="Instrument Sans"/>
-                <a:cs typeface="Instrument Sans"/>
-                <a:sym typeface="Instrument Sans"/>
-              </a:rPr>
-              <a:t>Labs train stronger models,</a:t>
-            </a:r>
-          </a:p>
-          <a:p>
-            <a:pPr marL="0" marR="0" lvl="0" indent="0" algn="l" rtl="0">
-              <a:lnSpc>
-                <a:spcPct val="110000"/>
-              </a:lnSpc>
-              <a:spcBef>
-                <a:spcPts val="0"/>
-              </a:spcBef>
-              <a:spcAft>
-                <a:spcPts val="0"/>
-              </a:spcAft>
-              <a:buNone/>
-            </a:pPr>
-            <a:r>
-              <a:rPr lang="en-US" sz="950" b="0" i="0" u="none" strike="noStrike" cap="none">
-                <a:solidFill>
-                  <a:srgbClr val="33322F"/>
-                </a:solidFill>
-                <a:latin typeface="Instrument Sans"/>
-                <a:ea typeface="Instrument Sans"/>
-                <a:cs typeface="Instrument Sans"/>
-                <a:sym typeface="Instrument Sans"/>
-              </a:rPr>
-              <a:t>bringing more personal agents</a:t>
-            </a:r>
-          </a:p>
-        </p:txBody>
-      </p:sp>
-      <p:sp>
-        <p:nvSpPr>
-          <p:cNvPr id="5048" name="SimReal 5048"/>
-          <p:cNvSpPr/>
-          <p:nvPr/>
-        </p:nvSpPr>
-        <p:spPr>
-          <a:xfrm>
-            <a:off x="10640873" y="4736592"/>
-            <a:ext cx="10973" cy="182880"/>
-          </a:xfrm>
-          <a:prstGeom prst="rect">
-            <a:avLst/>
-          </a:prstGeom>
-          <a:solidFill>
-            <a:srgbClr val="C4C0B7"/>
-          </a:solidFill>
-          <a:ln>
-            <a:noFill/>
-          </a:ln>
-        </p:spPr>
-        <p:txBody>
-          <a:bodyPr/>
-          <a:lstStyle/>
-          <a:p>
-            <a:endParaRPr/>
-          </a:p>
-        </p:txBody>
-      </p:sp>
-      <p:sp>
-        <p:nvSpPr>
-          <p:cNvPr id="5049" name="SimReal 5049"/>
-          <p:cNvSpPr/>
-          <p:nvPr/>
-        </p:nvSpPr>
-        <p:spPr>
-          <a:xfrm>
-            <a:off x="1548079" y="4919472"/>
-            <a:ext cx="9103766" cy="10973"/>
-          </a:xfrm>
-          <a:prstGeom prst="rect">
-            <a:avLst/>
-          </a:prstGeom>
-          <a:solidFill>
-            <a:srgbClr val="C4C0B7"/>
-          </a:solidFill>
-          <a:ln>
-            <a:noFill/>
-          </a:ln>
-        </p:spPr>
-        <p:txBody>
-          <a:bodyPr/>
-          <a:lstStyle/>
-          <a:p>
-            <a:endParaRPr/>
-          </a:p>
-        </p:txBody>
-      </p:sp>
-      <p:sp>
-        <p:nvSpPr>
-          <p:cNvPr id="5050" name="SimReal 5050"/>
-          <p:cNvSpPr/>
-          <p:nvPr/>
-        </p:nvSpPr>
-        <p:spPr>
-          <a:xfrm>
-            <a:off x="1548079" y="4828032"/>
-            <a:ext cx="10973" cy="100584"/>
-          </a:xfrm>
-          <a:prstGeom prst="rect">
-            <a:avLst/>
-          </a:prstGeom>
-          <a:solidFill>
-            <a:srgbClr val="C4C0B7"/>
-          </a:solidFill>
-          <a:ln>
-            <a:noFill/>
-          </a:ln>
-        </p:spPr>
-        <p:txBody>
-          <a:bodyPr/>
-          <a:lstStyle/>
-          <a:p>
-            <a:endParaRPr/>
-          </a:p>
-        </p:txBody>
-      </p:sp>
-      <p:sp>
-        <p:nvSpPr>
-          <p:cNvPr id="5051" name="SimReal 5051"/>
-          <p:cNvSpPr txBox="1"/>
-          <p:nvPr/>
-        </p:nvSpPr>
-        <p:spPr>
-          <a:xfrm>
-            <a:off x="1365199" y="4718304"/>
-            <a:ext cx="376733" cy="146304"/>
-          </a:xfrm>
-          <a:prstGeom prst="rect">
-            <a:avLst/>
-          </a:prstGeom>
-          <a:noFill/>
-          <a:ln>
-            <a:noFill/>
-          </a:ln>
-        </p:spPr>
-        <p:txBody>
-          <a:bodyPr spcFirstLastPara="1" wrap="square" lIns="0" tIns="0" rIns="0" bIns="0" anchor="ctr" anchorCtr="0">
-            <a:noAutofit/>
-          </a:bodyPr>
-          <a:lstStyle/>
-          <a:p>
-            <a:pPr marL="0" marR="0" lvl="0" indent="0" algn="ctr" rtl="0">
-              <a:spcBef>
-                <a:spcPts val="0"/>
-              </a:spcBef>
-              <a:spcAft>
-                <a:spcPts val="0"/>
-              </a:spcAft>
-              <a:buNone/>
-            </a:pPr>
-            <a:r>
-              <a:rPr lang="en-US" sz="900" b="0" i="0" u="none" strike="noStrike" cap="none">
-                <a:solidFill>
-                  <a:srgbClr val="6E6C66"/>
-                </a:solidFill>
-                <a:latin typeface="Instrument Sans"/>
-                <a:ea typeface="Instrument Sans"/>
-                <a:cs typeface="Instrument Sans"/>
-                <a:sym typeface="Instrument Sans"/>
-              </a:rPr>
-              <a:t>↑</a:t>
-            </a:r>
-          </a:p>
-        </p:txBody>
-      </p:sp>
-      <p:sp>
-        <p:nvSpPr>
-          <p:cNvPr id="5052" name="SimReal 5052"/>
-          <p:cNvSpPr txBox="1"/>
-          <p:nvPr/>
-        </p:nvSpPr>
-        <p:spPr>
-          <a:xfrm>
-            <a:off x="548640" y="5065776"/>
-            <a:ext cx="11091672" cy="329184"/>
-          </a:xfrm>
-          <a:prstGeom prst="rect">
-            <a:avLst/>
-          </a:prstGeom>
-          <a:noFill/>
-          <a:ln>
-            <a:noFill/>
-          </a:ln>
-        </p:spPr>
-        <p:txBody>
-          <a:bodyPr spcFirstLastPara="1" wrap="square" lIns="0" tIns="0" rIns="0" bIns="0" anchor="ctr" anchorCtr="0">
-            <a:noAutofit/>
-          </a:bodyPr>
-          <a:lstStyle/>
-          <a:p>
-            <a:pPr marL="0" marR="0" lvl="0" indent="0" algn="l" rtl="0">
-              <a:spcBef>
-                <a:spcPts val="0"/>
-              </a:spcBef>
-              <a:spcAft>
-                <a:spcPts val="0"/>
-              </a:spcAft>
-              <a:buNone/>
-            </a:pPr>
-            <a:r>
-              <a:rPr lang="en-US" sz="1000" b="1" i="0" u="none" strike="noStrike" cap="none">
-                <a:solidFill>
-                  <a:srgbClr val="C2410C"/>
-                </a:solidFill>
-                <a:latin typeface="IBM Plex Mono"/>
-                <a:ea typeface="IBM Plex Mono"/>
-                <a:cs typeface="IBM Plex Mono"/>
-                <a:sym typeface="IBM Plex Mono"/>
-              </a:rPr>
-              <a:t>Data rules   </a:t>
-            </a:r>
-            <a:r>
-              <a:rPr lang="en-US" sz="1050" b="0" i="0" u="none" strike="noStrike" cap="none">
-                <a:solidFill>
-                  <a:srgbClr val="111110"/>
-                </a:solidFill>
-                <a:latin typeface="Instrument Sans"/>
-                <a:ea typeface="Instrument Sans"/>
-                <a:cs typeface="Instrument Sans"/>
-                <a:sym typeface="Instrument Sans"/>
-              </a:rPr>
-              <a:t>Partners decide: pay to practice in private, or share de-identified runs for credits and a revenue share. Data reaches labs only with a license record.</a:t>
-            </a:r>
-          </a:p>
-        </p:txBody>
-      </p:sp>
-      <p:sp>
-        <p:nvSpPr>
-          <p:cNvPr id="5053" name="SimReal 5053"/>
-          <p:cNvSpPr txBox="1"/>
-          <p:nvPr/>
-        </p:nvSpPr>
-        <p:spPr>
-          <a:xfrm>
-            <a:off x="548640" y="5468112"/>
-            <a:ext cx="11091672" cy="420624"/>
-          </a:xfrm>
-          <a:prstGeom prst="rect">
-            <a:avLst/>
-          </a:prstGeom>
-          <a:noFill/>
-          <a:ln>
-            <a:noFill/>
-          </a:ln>
-        </p:spPr>
-        <p:txBody>
-          <a:bodyPr spcFirstLastPara="1" wrap="square" lIns="0" tIns="0" rIns="0" bIns="0" anchor="ctr" anchorCtr="0">
-            <a:noAutofit/>
-          </a:bodyPr>
-          <a:lstStyle/>
-          <a:p>
-            <a:pPr marL="0" marR="0" lvl="0" indent="0" algn="l" rtl="0">
-              <a:spcBef>
-                <a:spcPts val="0"/>
-              </a:spcBef>
-              <a:spcAft>
-                <a:spcPts val="0"/>
-              </a:spcAft>
-              <a:buNone/>
-            </a:pPr>
-            <a:r>
-              <a:rPr lang="en-US" sz="2000" b="0" i="0" u="none" strike="noStrike" cap="none">
-                <a:solidFill>
-                  <a:srgbClr val="111110"/>
-                </a:solidFill>
-                <a:latin typeface="Newsreader"/>
-                <a:ea typeface="Newsreader"/>
-                <a:cs typeface="Newsreader"/>
-                <a:sym typeface="Newsreader"/>
-              </a:rPr>
-              <a:t>Sandboxes keep agents out of trouble. </a:t>
-            </a:r>
-            <a:r>
-              <a:rPr lang="en-US" sz="2000" b="0" i="0" u="none" strike="noStrike" cap="none">
-                <a:solidFill>
-                  <a:srgbClr val="C2410C"/>
-                </a:solidFill>
-                <a:latin typeface="Newsreader"/>
-                <a:ea typeface="Newsreader"/>
-                <a:cs typeface="Newsreader"/>
-                <a:sym typeface="Newsreader"/>
-              </a:rPr>
-              <a:t>We teach them to get it right</a:t>
-            </a:r>
-            <a:r>
-              <a:rPr lang="en-US" sz="2000" b="0" i="0" u="none" strike="noStrike" cap="none">
-                <a:solidFill>
-                  <a:srgbClr val="111110"/>
-                </a:solidFill>
-                <a:latin typeface="Newsreader"/>
-                <a:ea typeface="Newsreader"/>
-                <a:cs typeface="Newsreader"/>
-                <a:sym typeface="Newsreader"/>
-              </a:rPr>
               <a:t>.</a:t>
             </a:r>
           </a:p>
@@ -32904,7 +31344,7 @@
       </p:sp>
       <p:sp>
         <p:nvSpPr>
-          <p:cNvPr id="5054" name="SimReal 5054"/>
+          <p:cNvPr id="5022" name="SimReal 5022"/>
           <p:cNvSpPr txBox="1"/>
           <p:nvPr/>
         </p:nvSpPr>
@@ -32946,14 +31386,14 @@
                 <a:cs typeface="Instrument Sans"/>
                 <a:sym typeface="Instrument Sans"/>
               </a:rPr>
-              <a:t>Sources: Meta and OpenAI launches (Sep 8 and 29, 2026); Bloomberg (Sep 21, 2026); Instinct (Sep 28, 2026); Remote Labor Index (Scale AI and CAIS, Jul 2026). See A2.</a:t>
-            </a:r>
-          </a:p>
-        </p:txBody>
-      </p:sp>
-      <p:sp>
-        <p:nvSpPr>
-          <p:cNvPr id="5055" name="SimReal 5055"/>
+              <a:t>Sources: Meta and OpenAI launches (Sep 8 and 29, 2026); Instinct (Sep 28, 2026); Remote Labor Index (Scale AI and CAIS, Jul 2026). See A2.</a:t>
+            </a:r>
+          </a:p>
+        </p:txBody>
+      </p:sp>
+      <p:sp>
+        <p:nvSpPr>
+          <p:cNvPr id="5023" name="SimReal 5023"/>
           <p:cNvSpPr txBox="1"/>
           <p:nvPr/>
         </p:nvSpPr>
@@ -33002,7 +31442,7 @@
       </p:sp>
       <p:sp>
         <p:nvSpPr>
-          <p:cNvPr id="5056" name="SimReal 5056"/>
+          <p:cNvPr id="5024" name="SimReal 5024"/>
           <p:cNvSpPr txBox="1"/>
           <p:nvPr/>
         </p:nvSpPr>

</xml_diff>

<commit_message>
BP v29 (ZH + EN): personal agents in the pitch, every number re-checked
- Cover adds the line 'Before a personal agent is trusted, it practices
  here'; the definition names personal agents
- Data refreshed to late Sep 2026: $8.5B restated as vendor revenue,
  Handshake replaces Snorkel in the top vendors, McKinsey agentic
  commerce replaces the Precedence forecast, Mechanize replaces the
  unverifiable Scale line, UniPat 'set to lead', AfterQuery 'reported',
  Applied Compute $3.25B raising, Apex Intelligence (RSI) comp
- Problem, insight and glossary wording updated (托付, PolyBench, RSI)
- A2 sources rewritten; bilingual intro added

Co-Authored-By: Claude Opus 5.5 <noreply@anthropic.com>
Claude-Session: https://claude.ai/code/session_01EKqGwTA92C8Wo4e47t73NN
</commit_message>
<xml_diff>
--- a/SimReal-BP-v29-EN.pptx
+++ b/SimReal-BP-v29-EN.pptx
@@ -5943,7 +5943,7 @@
         </p:nvSpPr>
         <p:spPr>
           <a:xfrm>
-            <a:off x="548640" y="1554480"/>
+            <a:off x="548640" y="1234440"/>
             <a:ext cx="7498080" cy="1737360"/>
           </a:xfrm>
           <a:prstGeom prst="rect">
@@ -6021,7 +6021,56 @@
         </p:nvSpPr>
         <p:spPr>
           <a:xfrm>
-            <a:off x="548640" y="3520440"/>
+            <a:off x="548640" y="3127248"/>
+            <a:ext cx="8046720" cy="420624"/>
+          </a:xfrm>
+          <a:prstGeom prst="rect">
+            <a:avLst/>
+          </a:prstGeom>
+          <a:noFill/>
+          <a:ln>
+            <a:noFill/>
+          </a:ln>
+        </p:spPr>
+        <p:txBody>
+          <a:bodyPr spcFirstLastPara="1" wrap="square" lIns="0" tIns="0" rIns="0" bIns="0" anchor="t" anchorCtr="0">
+            <a:noAutofit/>
+          </a:bodyPr>
+          <a:lstStyle/>
+          <a:p>
+            <a:pPr marL="0" marR="0" lvl="0" indent="0" algn="l" rtl="0">
+              <a:spcBef>
+                <a:spcPts val="0"/>
+              </a:spcBef>
+              <a:spcAft>
+                <a:spcPts val="0"/>
+              </a:spcAft>
+              <a:buNone/>
+            </a:pPr>
+            <a:r>
+              <a:rPr lang="en-US" sz="2100" b="0" i="0" u="none" strike="noStrike" cap="none">
+                <a:solidFill>
+                  <a:srgbClr val="111110"/>
+                </a:solidFill>
+                <a:latin typeface="Newsreader"/>
+                <a:ea typeface="Newsreader"/>
+                <a:cs typeface="Newsreader"/>
+                <a:sym typeface="Newsreader"/>
+              </a:rPr>
+              <a:t>Before a personal agent is trusted, it practices here</a:t>
+            </a:r>
+          </a:p>
+        </p:txBody>
+      </p:sp>
+      <p:sp>
+        <p:nvSpPr>
+          <p:cNvPr id="5003" name="SimReal 5003"/>
+          <p:cNvSpPr txBox="1"/>
+          <p:nvPr/>
+        </p:nvSpPr>
+        <p:spPr>
+          <a:xfrm>
+            <a:off x="548640" y="3749040"/>
             <a:ext cx="8595360" cy="329184"/>
           </a:xfrm>
           <a:prstGeom prst="rect">
@@ -6057,14 +6106,14 @@
                 <a:cs typeface="Instrument Sans"/>
                 <a:sym typeface="Instrument Sans"/>
               </a:rPr>
-              <a:t>Real worlds rebuilt from real data, where AI labs, enterprises and personal agents train</a:t>
-            </a:r>
-          </a:p>
-        </p:txBody>
-      </p:sp>
-      <p:sp>
-        <p:nvSpPr>
-          <p:cNvPr id="5003" name="SimReal 5003"/>
+              <a:t>Real situations rebuilt from real data, for AI labs, enterprises and personal agents</a:t>
+            </a:r>
+          </a:p>
+        </p:txBody>
+      </p:sp>
+      <p:sp>
+        <p:nvSpPr>
+          <p:cNvPr id="5004" name="SimReal 5004"/>
           <p:cNvSpPr/>
           <p:nvPr/>
         </p:nvSpPr>
@@ -6093,7 +6142,7 @@
       </p:sp>
       <p:sp>
         <p:nvSpPr>
-          <p:cNvPr id="5004" name="SimReal 5004"/>
+          <p:cNvPr id="5005" name="SimReal 5005"/>
           <p:cNvSpPr txBox="1"/>
           <p:nvPr/>
         </p:nvSpPr>
@@ -6142,7 +6191,7 @@
       </p:sp>
       <p:sp>
         <p:nvSpPr>
-          <p:cNvPr id="5005" name="SimReal 5005"/>
+          <p:cNvPr id="5006" name="SimReal 5006"/>
           <p:cNvSpPr txBox="1"/>
           <p:nvPr/>
         </p:nvSpPr>
@@ -6191,7 +6240,7 @@
       </p:sp>
       <p:sp>
         <p:nvSpPr>
-          <p:cNvPr id="5006" name="SimReal 5006"/>
+          <p:cNvPr id="5007" name="SimReal 5007"/>
           <p:cNvSpPr txBox="1"/>
           <p:nvPr/>
         </p:nvSpPr>
@@ -6240,7 +6289,7 @@
       </p:sp>
       <p:sp>
         <p:nvSpPr>
-          <p:cNvPr id="5007" name="SimReal 5007"/>
+          <p:cNvPr id="5008" name="SimReal 5008"/>
           <p:cNvSpPr txBox="1"/>
           <p:nvPr/>
         </p:nvSpPr>
@@ -6289,7 +6338,7 @@
       </p:sp>
       <p:sp>
         <p:nvSpPr>
-          <p:cNvPr id="5008" name="SimReal 5008"/>
+          <p:cNvPr id="5009" name="SimReal 5009"/>
           <p:cNvSpPr txBox="1"/>
           <p:nvPr/>
         </p:nvSpPr>
@@ -8140,7 +8189,7 @@
                 <a:cs typeface="Newsreader"/>
                 <a:sym typeface="Newsreader"/>
               </a:rPr>
-              <a:t>Labs spend $8.5B a year on training data and RL environments: </a:t>
+              <a:t>Training data and RL environments are already a ~$8.5B-a-year business: </a:t>
             </a:r>
             <a:r>
               <a:rPr lang="en-US" sz="1800" b="0" i="0" u="none" strike="noStrike" cap="none">
@@ -14727,7 +14776,7 @@
                 <a:cs typeface="IBM Plex Mono"/>
                 <a:sym typeface="IBM Plex Mono"/>
               </a:rPr>
-              <a:t>Today · what labs buy</a:t>
+              <a:t>Today · vendor revenue</a:t>
             </a:r>
           </a:p>
         </p:txBody>
@@ -14825,7 +14874,7 @@
                 <a:cs typeface="Instrument Sans"/>
                 <a:sym typeface="Instrument Sans"/>
               </a:rPr>
-              <a:t>Training data and RL environments, 50+ vendors</a:t>
+              <a:t>50+ training-data and RL-environment vendors</a:t>
             </a:r>
           </a:p>
         </p:txBody>
@@ -14874,7 +14923,7 @@
                 <a:cs typeface="Instrument Sans"/>
                 <a:sym typeface="Instrument Sans"/>
               </a:rPr>
-              <a:t>Top three by revenue (Surge: 2024; others run-rate)</a:t>
+              <a:t>Leading vendors (Surge: 2024; others gross run-rate)</a:t>
             </a:r>
           </a:p>
         </p:txBody>
@@ -15177,7 +15226,7 @@
                 <a:cs typeface="Newsreader"/>
                 <a:sym typeface="Newsreader"/>
               </a:rPr>
-              <a:t>Snorkel AI</a:t>
+              <a:t>Handshake</a:t>
             </a:r>
           </a:p>
         </p:txBody>
@@ -15191,7 +15240,7 @@
         <p:spPr>
           <a:xfrm>
             <a:off x="1600200" y="4014216"/>
-            <a:ext cx="257175" cy="219456"/>
+            <a:ext cx="685800" cy="219456"/>
           </a:xfrm>
           <a:prstGeom prst="rect">
             <a:avLst/>
@@ -15219,7 +15268,7 @@
         </p:nvSpPr>
         <p:spPr>
           <a:xfrm>
-            <a:off x="1930527" y="3986784"/>
+            <a:off x="2359152" y="3986784"/>
             <a:ext cx="1005840" cy="274320"/>
           </a:xfrm>
           <a:prstGeom prst="rect">
@@ -15255,7 +15304,7 @@
                 <a:cs typeface="Instrument Sans"/>
                 <a:sym typeface="Instrument Sans"/>
               </a:rPr>
-              <a:t>$375M</a:t>
+              <a:t>~$1.0B</a:t>
             </a:r>
           </a:p>
         </p:txBody>
@@ -16566,7 +16615,7 @@
                 <a:cs typeface="Instrument Sans"/>
                 <a:sym typeface="Instrument Sans"/>
               </a:rPr>
-              <a:t>Sources: Menlo Ventures (Jul 2026); Mercor gross run-rate (Jun 2026), Surge revenue (2024), Snorkel run-rate (Sep 2026); McKinsey (Nov 2025); IMF (Apr 2026); company filings.</a:t>
+              <a:t>Sources: Deedy Das, Menlo Ventures (Jul 2026); Mercor gross run-rate (Jun 2026), Handshake AI training (Apr 2026), Surge revenue (2024); McKinsey (Nov 2025); IMF (Apr 2026); company filings.</a:t>
             </a:r>
           </a:p>
           <a:p>
@@ -17205,7 +17254,7 @@
                 <a:cs typeface="IBM Plex Mono"/>
                 <a:sym typeface="IBM Plex Mono"/>
               </a:rPr>
-              <a:t>Mercor, Surge, AfterQuery</a:t>
+              <a:t>Mercor, Surge, Handshake, AfterQuery</a:t>
             </a:r>
           </a:p>
         </p:txBody>
@@ -17258,6 +17307,32 @@
                 <a:sym typeface="Instrument Sans"/>
               </a:rPr>
               <a:t>Expert demos and judgments, human-graded</a:t>
+            </a:r>
+          </a:p>
+          <a:p>
+            <a:pPr marL="0" marR="0" lvl="0" indent="0" algn="l" rtl="0">
+              <a:lnSpc>
+                <a:spcPct val="110000"/>
+              </a:lnSpc>
+              <a:spcBef>
+                <a:spcPts val="384"/>
+              </a:spcBef>
+              <a:spcAft>
+                <a:spcPts val="0"/>
+              </a:spcAft>
+              <a:buNone/>
+            </a:pPr>
+            <a:r>
+              <a:rPr lang="en-US" sz="1100" b="0" i="0" u="none" strike="noStrike" cap="none">
+                <a:solidFill>
+                  <a:srgbClr val="33322F"/>
+                </a:solidFill>
+                <a:latin typeface="Instrument Sans"/>
+                <a:ea typeface="Instrument Sans"/>
+                <a:cs typeface="Instrument Sans"/>
+                <a:sym typeface="Instrument Sans"/>
+              </a:rPr>
+              <a:t>Mercor bought RL-environment maker Deeptune</a:t>
             </a:r>
           </a:p>
         </p:txBody>
@@ -17436,7 +17511,33 @@
                 <a:cs typeface="Instrument Sans"/>
                 <a:sym typeface="Instrument Sans"/>
               </a:rPr>
-              <a:t>Mainly serve Chinese labs: expert data and evals</a:t>
+              <a:t>Expert data, eval environments and benchmarks;</a:t>
+            </a:r>
+          </a:p>
+          <a:p>
+            <a:pPr marL="0" marR="0" lvl="0" indent="0" algn="l" rtl="0">
+              <a:lnSpc>
+                <a:spcPct val="110000"/>
+              </a:lnSpc>
+              <a:spcBef>
+                <a:spcPts val="384"/>
+              </a:spcBef>
+              <a:spcAft>
+                <a:spcPts val="0"/>
+              </a:spcAft>
+              <a:buNone/>
+            </a:pPr>
+            <a:r>
+              <a:rPr lang="en-US" sz="1100" b="0" i="0" u="none" strike="noStrike" cap="none">
+                <a:solidFill>
+                  <a:srgbClr val="33322F"/>
+                </a:solidFill>
+                <a:latin typeface="Instrument Sans"/>
+                <a:ea typeface="Instrument Sans"/>
+                <a:cs typeface="Instrument Sans"/>
+                <a:sym typeface="Instrument Sans"/>
+              </a:rPr>
+              <a:t>mainly for Chinese labs</a:t>
             </a:r>
           </a:p>
         </p:txBody>
@@ -18534,7 +18635,7 @@
                 <a:cs typeface="Instrument Sans"/>
                 <a:sym typeface="Instrument Sans"/>
               </a:rPr>
-              <a:t>Per Bloomberg, Alibaba led a $300M round in UniPat at a $2.5B valuation; Humanlaya closed a CDH-led Pre-A of several hundred million RMB;</a:t>
+              <a:t>Per Bloomberg, Alibaba is set to lead a $300M round in UniPat at a $2.5B valuation; Humanlaya closed a CDH-led Pre-A of several hundred million RMB;</a:t>
             </a:r>
             <a:br>
               <a:rPr lang="en-US" sz="1000"/>
@@ -18549,7 +18650,7 @@
                 <a:cs typeface="Instrument Sans"/>
                 <a:sym typeface="Instrument Sans"/>
               </a:rPr>
-              <a:t>Alibaba, ByteDance and DeepSeek already buy from both.</a:t>
+              <a:t>Alibaba, ByteDance, DeepSeek and others have bought data or services from both.</a:t>
             </a:r>
           </a:p>
         </p:txBody>
@@ -19049,7 +19150,7 @@
         <p:spPr>
           <a:xfrm>
             <a:off x="548640" y="1499616"/>
-            <a:ext cx="8229600" cy="201168"/>
+            <a:ext cx="10058400" cy="201168"/>
           </a:xfrm>
           <a:prstGeom prst="rect">
             <a:avLst/>
@@ -19084,7 +19185,7 @@
                 <a:cs typeface="IBM Plex Mono"/>
                 <a:sym typeface="IBM Plex Mono"/>
               </a:rPr>
-              <a:t>Every wave was won by the fastest young team</a:t>
+              <a:t>Every wave was won by the fastest young team; in personal agents, Instinct’s founder is 23</a:t>
             </a:r>
           </a:p>
         </p:txBody>
@@ -20618,7 +20719,33 @@
                 <a:cs typeface="Instrument Sans"/>
                 <a:sym typeface="Instrument Sans"/>
               </a:rPr>
-              <a:t>Valuation, 18 months after YC</a:t>
+              <a:t>Reported valuation,</a:t>
+            </a:r>
+          </a:p>
+          <a:p>
+            <a:pPr marL="0" marR="0" lvl="0" indent="0" algn="l" rtl="0">
+              <a:lnSpc>
+                <a:spcPct val="100000"/>
+              </a:lnSpc>
+              <a:spcBef>
+                <a:spcPts val="0"/>
+              </a:spcBef>
+              <a:spcAft>
+                <a:spcPts val="0"/>
+              </a:spcAft>
+              <a:buNone/>
+            </a:pPr>
+            <a:r>
+              <a:rPr lang="en-US" sz="1000" b="0" i="0" u="none" strike="noStrike" cap="none">
+                <a:solidFill>
+                  <a:srgbClr val="33322F"/>
+                </a:solidFill>
+                <a:latin typeface="Instrument Sans"/>
+                <a:ea typeface="Instrument Sans"/>
+                <a:cs typeface="Instrument Sans"/>
+                <a:sym typeface="Instrument Sans"/>
+              </a:rPr>
+              <a:t>18 months after YC</a:t>
             </a:r>
           </a:p>
         </p:txBody>
@@ -20699,7 +20826,33 @@
                 <a:cs typeface="Instrument Sans"/>
                 <a:sym typeface="Instrument Sans"/>
               </a:rPr>
-              <a:t>Founded by two students around 21</a:t>
+              <a:t>Founded by two high-school</a:t>
+            </a:r>
+          </a:p>
+          <a:p>
+            <a:pPr marL="0" marR="0" lvl="0" indent="0" algn="l" rtl="0">
+              <a:lnSpc>
+                <a:spcPct val="100000"/>
+              </a:lnSpc>
+              <a:spcBef>
+                <a:spcPts val="0"/>
+              </a:spcBef>
+              <a:spcAft>
+                <a:spcPts val="0"/>
+              </a:spcAft>
+              <a:buNone/>
+            </a:pPr>
+            <a:r>
+              <a:rPr lang="en-US" sz="1000" b="0" i="0" u="none" strike="noStrike" cap="none">
+                <a:solidFill>
+                  <a:srgbClr val="33322F"/>
+                </a:solidFill>
+                <a:latin typeface="Instrument Sans"/>
+                <a:ea typeface="Instrument Sans"/>
+                <a:cs typeface="Instrument Sans"/>
+                <a:sym typeface="Instrument Sans"/>
+              </a:rPr>
+              <a:t>friends, now 22 and 23</a:t>
             </a:r>
           </a:p>
         </p:txBody>
@@ -22789,7 +22942,7 @@
                 <a:cs typeface="Instrument Sans"/>
                 <a:sym typeface="Instrument Sans"/>
               </a:rPr>
-              <a:t>Alibaba led; Tencent, HongShan joined</a:t>
+              <a:t>Alibaba to lead; Tencent, HSG in</a:t>
             </a:r>
           </a:p>
         </p:txBody>
@@ -22867,7 +23020,7 @@
                 <a:cs typeface="IBM Plex Mono"/>
                 <a:sym typeface="IBM Plex Mono"/>
               </a:rPr>
-              <a:t>China · Humanlaya</a:t>
+              <a:t>China · Apex Intelligence</a:t>
             </a:r>
           </a:p>
         </p:txBody>
@@ -22916,7 +23069,7 @@
                 <a:cs typeface="Newsreader"/>
                 <a:sym typeface="Newsreader"/>
               </a:rPr>
-              <a:t>Hundreds of millions</a:t>
+              <a:t>~RMB 400M</a:t>
             </a:r>
           </a:p>
         </p:txBody>
@@ -22965,7 +23118,7 @@
                 <a:cs typeface="Instrument Sans"/>
                 <a:sym typeface="Instrument Sans"/>
               </a:rPr>
-              <a:t>Pre-A round size in RMB (Sep 2026)</a:t>
+              <a:t>RSI angel rounds (Sep 2026)</a:t>
             </a:r>
           </a:p>
         </p:txBody>
@@ -23017,7 +23170,7 @@
                 <a:cs typeface="Instrument Sans"/>
                 <a:sym typeface="Instrument Sans"/>
               </a:rPr>
-              <a:t>CDH led; HongShan and others joined</a:t>
+              <a:t>Led by IDG Capital and others</a:t>
             </a:r>
           </a:p>
         </p:txBody>
@@ -23144,7 +23297,7 @@
                 <a:cs typeface="Newsreader"/>
                 <a:sym typeface="Newsreader"/>
               </a:rPr>
-              <a:t>$100M → ~$3B</a:t>
+              <a:t>$100M → $3.25B</a:t>
             </a:r>
           </a:p>
         </p:txBody>
@@ -23193,7 +23346,7 @@
                 <a:cs typeface="Instrument Sans"/>
                 <a:sym typeface="Instrument Sans"/>
               </a:rPr>
-              <a:t>Seed post → 14 months later (in talks)</a:t>
+              <a:t>Seed → 15 months later (raising)</a:t>
             </a:r>
           </a:p>
         </p:txBody>
@@ -23421,7 +23574,7 @@
                 <a:cs typeface="Instrument Sans"/>
                 <a:sym typeface="Instrument Sans"/>
               </a:rPr>
-              <a:t>Series A → 5 months later</a:t>
+              <a:t>Series A → 5 months later (reported)</a:t>
             </a:r>
           </a:p>
         </p:txBody>
@@ -23522,7 +23675,7 @@
                 <a:cs typeface="Newsreader"/>
                 <a:sym typeface="Newsreader"/>
               </a:rPr>
-              <a:t>HongShan, CDH, Capital Today, BAI, Alibaba and Tencent are already in: </a:t>
+              <a:t>HSG, CDH, Capital Today, BAI and IDG are in; Alibaba and Tencent are moving in: </a:t>
             </a:r>
             <a:r>
               <a:rPr lang="en-US" sz="1600" b="0" i="0" u="none" strike="noStrike" cap="none">
@@ -23595,7 +23748,7 @@
                 <a:cs typeface="Instrument Sans"/>
                 <a:sym typeface="Instrument Sans"/>
               </a:rPr>
-              <a:t>UniPat: reported valuation; Applied Compute ~$3B: valuation in talks; Humanlaya: round size; others post-money. Sources in A2.</a:t>
+              <a:t>UniPat and AfterQuery $3.2B: reported valuations; Applied Compute $3.25B: round in progress; Apex: round size; others post-money. Sources in A2.</a:t>
             </a:r>
           </a:p>
         </p:txBody>
@@ -28613,7 +28766,7 @@
                 <a:cs typeface="Instrument Sans"/>
                 <a:sym typeface="Instrument Sans"/>
               </a:rPr>
-              <a:t>Labs buy $8.5B a year of data and RL environments</a:t>
+              <a:t>Data and RL-environment vendors earn ~$8.5B a year</a:t>
             </a:r>
           </a:p>
           <a:p>
@@ -29808,7 +29961,7 @@
                 <a:cs typeface="Instrument Sans"/>
                 <a:sym typeface="Instrument Sans"/>
               </a:rPr>
-              <a:t>Xitadel public preview: human baseline 80; best frontier model 77.28 (GPT 6); no model has passed the human baseline yet</a:t>
+              <a:t>Xitadel public preview: human baseline 80; best frontier model 77.28 (GPT-6); no model has passed the human baseline yet</a:t>
             </a:r>
           </a:p>
         </p:txBody>
@@ -30464,7 +30617,7 @@
         <p:spPr>
           <a:xfrm>
             <a:off x="548640" y="1499616"/>
-            <a:ext cx="7315200" cy="201168"/>
+            <a:ext cx="10058400" cy="201168"/>
           </a:xfrm>
           <a:prstGeom prst="rect">
             <a:avLst/>
@@ -30499,7 +30652,7 @@
                 <a:cs typeface="IBM Plex Mono"/>
                 <a:sym typeface="IBM Plex Mono"/>
               </a:rPr>
-              <a:t>Personal agents are here</a:t>
+              <a:t>September 2026: personal agents arrive; in China, Qwen and Manus follow the same month</a:t>
             </a:r>
           </a:p>
         </p:txBody>
@@ -30629,7 +30782,33 @@
                 <a:cs typeface="Instrument Sans"/>
                 <a:sym typeface="Instrument Sans"/>
               </a:rPr>
-              <a:t>Meta, launched Sep 8</a:t>
+              <a:t>Meta, launched Sep 8;</a:t>
+            </a:r>
+          </a:p>
+          <a:p>
+            <a:pPr marL="0" marR="0" lvl="0" indent="0" algn="l" rtl="0">
+              <a:lnSpc>
+                <a:spcPct val="110000"/>
+              </a:lnSpc>
+              <a:spcBef>
+                <a:spcPts val="0"/>
+              </a:spcBef>
+              <a:spcAft>
+                <a:spcPts val="0"/>
+              </a:spcAft>
+              <a:buNone/>
+            </a:pPr>
+            <a:r>
+              <a:rPr lang="en-US" sz="1150" b="0" i="0" u="none" strike="noStrike" cap="none">
+                <a:solidFill>
+                  <a:srgbClr val="33322F"/>
+                </a:solidFill>
+                <a:latin typeface="Instrument Sans"/>
+                <a:ea typeface="Instrument Sans"/>
+                <a:cs typeface="Instrument Sans"/>
+                <a:sym typeface="Instrument Sans"/>
+              </a:rPr>
+              <a:t>No. 1 on the US App Store in 10 days</a:t>
             </a:r>
           </a:p>
         </p:txBody>
@@ -30759,7 +30938,33 @@
                 <a:cs typeface="Instrument Sans"/>
                 <a:sym typeface="Instrument Sans"/>
               </a:rPr>
-              <a:t>OpenAI, unveiled Sep 29</a:t>
+              <a:t>OpenAI, unveiled Sep 29;</a:t>
+            </a:r>
+          </a:p>
+          <a:p>
+            <a:pPr marL="0" marR="0" lvl="0" indent="0" algn="l" rtl="0">
+              <a:lnSpc>
+                <a:spcPct val="110000"/>
+              </a:lnSpc>
+              <a:spcBef>
+                <a:spcPts val="0"/>
+              </a:spcBef>
+              <a:spcAft>
+                <a:spcPts val="0"/>
+              </a:spcAft>
+              <a:buNone/>
+            </a:pPr>
+            <a:r>
+              <a:rPr lang="en-US" sz="1150" b="0" i="0" u="none" strike="noStrike" cap="none">
+                <a:solidFill>
+                  <a:srgbClr val="33322F"/>
+                </a:solidFill>
+                <a:latin typeface="Instrument Sans"/>
+                <a:ea typeface="Instrument Sans"/>
+                <a:cs typeface="Instrument Sans"/>
+                <a:sym typeface="Instrument Sans"/>
+              </a:rPr>
+              <a:t>always-on in the cloud</a:t>
             </a:r>
           </a:p>
         </p:txBody>
@@ -30889,7 +31094,33 @@
                 <a:cs typeface="Instrument Sans"/>
                 <a:sym typeface="Instrument Sans"/>
               </a:rPr>
-              <a:t>Instinct, up 4x in 33 days</a:t>
+              <a:t>Instinct’s valuation, up 4x in 33 days;</a:t>
+            </a:r>
+          </a:p>
+          <a:p>
+            <a:pPr marL="0" marR="0" lvl="0" indent="0" algn="l" rtl="0">
+              <a:lnSpc>
+                <a:spcPct val="110000"/>
+              </a:lnSpc>
+              <a:spcBef>
+                <a:spcPts val="0"/>
+              </a:spcBef>
+              <a:spcAft>
+                <a:spcPts val="0"/>
+              </a:spcAft>
+              <a:buNone/>
+            </a:pPr>
+            <a:r>
+              <a:rPr lang="en-US" sz="1150" b="0" i="0" u="none" strike="noStrike" cap="none">
+                <a:solidFill>
+                  <a:srgbClr val="33322F"/>
+                </a:solidFill>
+                <a:latin typeface="Instrument Sans"/>
+                <a:ea typeface="Instrument Sans"/>
+                <a:cs typeface="Instrument Sans"/>
+                <a:sym typeface="Instrument Sans"/>
+              </a:rPr>
+              <a:t>Sequoia, Benchmark, Coatue</a:t>
             </a:r>
           </a:p>
         </p:txBody>
@@ -31386,7 +31617,7 @@
                 <a:cs typeface="Instrument Sans"/>
                 <a:sym typeface="Instrument Sans"/>
               </a:rPr>
-              <a:t>Sources: Meta and OpenAI launches (Sep 8 and 29, 2026); Instinct (Sep 28, 2026); Remote Labor Index (Scale AI and CAIS, Jul 2026). See A2.</a:t>
+              <a:t>Sources: Meta, OpenAI, Qwen and Manus launches (Sep 2026); TechCrunch (Sep 25, 2026); Instinct (Reuters, Sep 28, 2026); Remote Labor Index (Scale AI and CAIS, Jul 2026). See A2.</a:t>
             </a:r>
           </a:p>
         </p:txBody>
@@ -31764,7 +31995,7 @@
           <a:p>
             <a:pPr marL="0" marR="0" lvl="0" indent="0" algn="l" rtl="0">
               <a:lnSpc>
-                <a:spcPct val="110000"/>
+                <a:spcPct val="108000"/>
               </a:lnSpc>
               <a:spcBef>
                 <a:spcPts val="0"/>
@@ -31796,16 +32027,16 @@
                 <a:cs typeface="Instrument Sans"/>
                 <a:sym typeface="Instrument Sans"/>
               </a:rPr>
-              <a:t>TechCrunch (Feb 2025, $75M); CEO (Sep 2025, $500M); Sacra (Dec 2025, $760M); Mercor (early 2026, $1B); Dealroom (Jun 2026, $2B). All gross; experts take 60–70% (Bloomberg)</a:t>
+              <a:t>TechCrunch (Feb 2025, $75M); Sacra (Dec 2025, $760M); Dealroom and Forbes (Jun 2026, $2B). All gross; experts take 60–70% (Bloomberg)</a:t>
             </a:r>
           </a:p>
           <a:p>
             <a:pPr marL="0" marR="0" lvl="0" indent="0" algn="l" rtl="0">
               <a:lnSpc>
-                <a:spcPct val="110000"/>
+                <a:spcPct val="108000"/>
               </a:lnSpc>
               <a:spcBef>
-                <a:spcPts val="500"/>
+                <a:spcPts val="300"/>
               </a:spcBef>
               <a:spcAft>
                 <a:spcPts val="0"/>
@@ -31822,7 +32053,7 @@
                 <a:cs typeface="Instrument Sans"/>
                 <a:sym typeface="Instrument Sans"/>
               </a:rPr>
-              <a:t>Mercor valuation: </a:t>
+              <a:t>Mercor valuation and M&amp;A: </a:t>
             </a:r>
             <a:r>
               <a:rPr lang="en-US" sz="850" b="0" i="0" u="none" strike="noStrike" cap="none">
@@ -31834,16 +32065,16 @@
                 <a:cs typeface="Instrument Sans"/>
                 <a:sym typeface="Instrument Sans"/>
               </a:rPr>
-              <a:t>Series A $250M (Sep 2024), Series B $2B (Feb 2025), Series C $10B (Oct 2025); a $20B round in early talks (Bloomberg, Jul 9, 2026)</a:t>
+              <a:t>Series C $10B (Oct 2025); a $20B round still in talks (Bloomberg, Jul 9, 2026; The Information, Aug 2026); bought RL-environment startup Deeptune on Jul 9, 2026 (Forbes)</a:t>
             </a:r>
           </a:p>
           <a:p>
             <a:pPr marL="0" marR="0" lvl="0" indent="0" algn="l" rtl="0">
               <a:lnSpc>
-                <a:spcPct val="110000"/>
+                <a:spcPct val="108000"/>
               </a:lnSpc>
               <a:spcBef>
-                <a:spcPts val="500"/>
+                <a:spcPts val="300"/>
               </a:spcBef>
               <a:spcAft>
                 <a:spcPts val="0"/>
@@ -31878,10 +32109,10 @@
           <a:p>
             <a:pPr marL="0" marR="0" lvl="0" indent="0" algn="l" rtl="0">
               <a:lnSpc>
-                <a:spcPct val="110000"/>
+                <a:spcPct val="108000"/>
               </a:lnSpc>
               <a:spcBef>
-                <a:spcPts val="500"/>
+                <a:spcPts val="300"/>
               </a:spcBef>
               <a:spcAft>
                 <a:spcPts val="0"/>
@@ -31898,6 +32129,44 @@
                 <a:cs typeface="Instrument Sans"/>
                 <a:sym typeface="Instrument Sans"/>
               </a:rPr>
+              <a:t>Handshake: </a:t>
+            </a:r>
+            <a:r>
+              <a:rPr lang="en-US" sz="850" b="0" i="0" u="none" strike="noStrike" cap="none">
+                <a:solidFill>
+                  <a:srgbClr val="33322F"/>
+                </a:solidFill>
+                <a:latin typeface="Instrument Sans"/>
+                <a:ea typeface="Instrument Sans"/>
+                <a:cs typeface="Instrument Sans"/>
+                <a:sym typeface="Instrument Sans"/>
+              </a:rPr>
+              <a:t>AI-training business at nearly $1B gross run-rate (The Information, Apr 2026)</a:t>
+            </a:r>
+          </a:p>
+          <a:p>
+            <a:pPr marL="0" marR="0" lvl="0" indent="0" algn="l" rtl="0">
+              <a:lnSpc>
+                <a:spcPct val="108000"/>
+              </a:lnSpc>
+              <a:spcBef>
+                <a:spcPts val="300"/>
+              </a:spcBef>
+              <a:spcAft>
+                <a:spcPts val="0"/>
+              </a:spcAft>
+              <a:buNone/>
+            </a:pPr>
+            <a:r>
+              <a:rPr lang="en-US" sz="850" b="1" i="0" u="none" strike="noStrike" cap="none">
+                <a:solidFill>
+                  <a:srgbClr val="111110"/>
+                </a:solidFill>
+                <a:latin typeface="Instrument Sans"/>
+                <a:ea typeface="Instrument Sans"/>
+                <a:cs typeface="Instrument Sans"/>
+                <a:sym typeface="Instrument Sans"/>
+              </a:rPr>
               <a:t>Snorkel AI: </a:t>
             </a:r>
             <a:r>
@@ -31910,16 +32179,16 @@
                 <a:cs typeface="Instrument Sans"/>
                 <a:sym typeface="Instrument Sans"/>
               </a:rPr>
-              <a:t>Company and TechCrunch, Sep 22, 2026 ($350M raised at a $3.5B valuation; $375M run-rate, up 18x in a year)</a:t>
+              <a:t>Reuters and TechCrunch, Sep 22, 2026 ($350M raised at a $3.5B valuation; $375M run-rate, up ~18x in a year)</a:t>
             </a:r>
           </a:p>
           <a:p>
             <a:pPr marL="0" marR="0" lvl="0" indent="0" algn="l" rtl="0">
               <a:lnSpc>
-                <a:spcPct val="110000"/>
+                <a:spcPct val="108000"/>
               </a:lnSpc>
               <a:spcBef>
-                <a:spcPts val="500"/>
+                <a:spcPts val="300"/>
               </a:spcBef>
               <a:spcAft>
                 <a:spcPts val="0"/>
@@ -31948,16 +32217,16 @@
                 <a:cs typeface="Instrument Sans"/>
                 <a:sym typeface="Instrument Sans"/>
               </a:rPr>
-              <a:t>Founded Feb 2025; Forbes, Sep 1, 2026 (18 months after YC, $3.2B valuation); Business Wire (Apr 2026, Series A at $300M, $100M run-rate); YC profile (co-founder interned at Citadel Securities)</a:t>
+              <a:t>Founded Feb 2025; Business Wire (Apr 2026, Series A at $300M, $100M run-rate); Forbes and TechCrunch (Sep 1, 2026, reported $3.2B valuation; founders are high-school friends, now 22 and 23); YC profile (co-founder interned at Citadel Securities)</a:t>
             </a:r>
           </a:p>
           <a:p>
             <a:pPr marL="0" marR="0" lvl="0" indent="0" algn="l" rtl="0">
               <a:lnSpc>
-                <a:spcPct val="110000"/>
+                <a:spcPct val="108000"/>
               </a:lnSpc>
               <a:spcBef>
-                <a:spcPts val="500"/>
+                <a:spcPts val="300"/>
               </a:spcBef>
               <a:spcAft>
                 <a:spcPts val="0"/>
@@ -31986,16 +32255,16 @@
                 <a:cs typeface="Instrument Sans"/>
                 <a:sym typeface="Instrument Sans"/>
               </a:rPr>
-              <a:t>Founded in 2016 by Alexandr Wang, then 19 (Forbes); Meta bought 49% for $14.3B, ~$29B valuation (Reuters, Jun 2025); nearly half of new training projects involve RL environments (Scale AI blog, Feb 2026)</a:t>
+              <a:t>Founded in 2016 by Alexandr Wang, then 19 (Forbes); Meta bought 49% for $14.3B, ~$29B valuation (Reuters, Jun 2025)</a:t>
             </a:r>
           </a:p>
           <a:p>
             <a:pPr marL="0" marR="0" lvl="0" indent="0" algn="l" rtl="0">
               <a:lnSpc>
-                <a:spcPct val="110000"/>
+                <a:spcPct val="108000"/>
               </a:lnSpc>
               <a:spcBef>
-                <a:spcPts val="500"/>
+                <a:spcPts val="300"/>
               </a:spcBef>
               <a:spcAft>
                 <a:spcPts val="0"/>
@@ -32012,6 +32281,44 @@
                 <a:cs typeface="Instrument Sans"/>
                 <a:sym typeface="Instrument Sans"/>
               </a:rPr>
+              <a:t>Mechanize: </a:t>
+            </a:r>
+            <a:r>
+              <a:rPr lang="en-US" sz="850" b="0" i="0" u="none" strike="noStrike" cap="none">
+                <a:solidFill>
+                  <a:srgbClr val="33322F"/>
+                </a:solidFill>
+                <a:latin typeface="Instrument Sans"/>
+                <a:ea typeface="Instrument Sans"/>
+                <a:cs typeface="Instrument Sans"/>
+                <a:sym typeface="Instrument Sans"/>
+              </a:rPr>
+              <a:t>Business Insider (Aug and Sep 2026): Google talent and licensing deal, reportedly over $1.5B</a:t>
+            </a:r>
+          </a:p>
+          <a:p>
+            <a:pPr marL="0" marR="0" lvl="0" indent="0" algn="l" rtl="0">
+              <a:lnSpc>
+                <a:spcPct val="108000"/>
+              </a:lnSpc>
+              <a:spcBef>
+                <a:spcPts val="300"/>
+              </a:spcBef>
+              <a:spcAft>
+                <a:spcPts val="0"/>
+              </a:spcAft>
+              <a:buNone/>
+            </a:pPr>
+            <a:r>
+              <a:rPr lang="en-US" sz="850" b="1" i="0" u="none" strike="noStrike" cap="none">
+                <a:solidFill>
+                  <a:srgbClr val="111110"/>
+                </a:solidFill>
+                <a:latin typeface="Instrument Sans"/>
+                <a:ea typeface="Instrument Sans"/>
+                <a:cs typeface="Instrument Sans"/>
+                <a:sym typeface="Instrument Sans"/>
+              </a:rPr>
               <a:t>UniPat: </a:t>
             </a:r>
             <a:r>
@@ -32024,16 +32331,16 @@
                 <a:cs typeface="Instrument Sans"/>
                 <a:sym typeface="Instrument Sans"/>
               </a:rPr>
-              <a:t>Bloomberg, Sep 10, 2026 (Alibaba-led $300M round, reported $2.5B valuation, with Tencent and HongShan; terms may change; Alibaba, ByteDance, DeepSeek and others buy from UniPat and Humanlaya)</a:t>
+              <a:t>Bloomberg, Sep 10, 2026 (Alibaba set to lead a $300M round at a reported $2.5B valuation, with Tencent and HSG; talks ongoing; Alibaba, ByteDance, DeepSeek and others have bought data or services from UniPat and Humanlaya); 36Kr (Sep 24, 2026)</a:t>
             </a:r>
           </a:p>
           <a:p>
             <a:pPr marL="0" marR="0" lvl="0" indent="0" algn="l" rtl="0">
               <a:lnSpc>
-                <a:spcPct val="110000"/>
+                <a:spcPct val="108000"/>
               </a:lnSpc>
               <a:spcBef>
-                <a:spcPts val="500"/>
+                <a:spcPts val="300"/>
               </a:spcBef>
               <a:spcAft>
                 <a:spcPts val="0"/>
@@ -32062,7 +32369,45 @@
                 <a:cs typeface="Instrument Sans"/>
                 <a:sym typeface="Instrument Sans"/>
               </a:rPr>
-              <a:t>Founded Oct 2025; Pre-A of several hundred million RMB on Sep 9, 2026, led by CDH with HongShan, Capital Today and BAI (Jiemian, Eastmoney)</a:t>
+              <a:t>Founded 2025; Pre-A of several hundred million RMB in Sep 2026, led by CDH with HSG, Capital Today and BAI (Jiemian, Eastmoney)</a:t>
+            </a:r>
+          </a:p>
+          <a:p>
+            <a:pPr marL="0" marR="0" lvl="0" indent="0" algn="l" rtl="0">
+              <a:lnSpc>
+                <a:spcPct val="108000"/>
+              </a:lnSpc>
+              <a:spcBef>
+                <a:spcPts val="300"/>
+              </a:spcBef>
+              <a:spcAft>
+                <a:spcPts val="0"/>
+              </a:spcAft>
+              <a:buNone/>
+            </a:pPr>
+            <a:r>
+              <a:rPr lang="en-US" sz="850" b="1" i="0" u="none" strike="noStrike" cap="none">
+                <a:solidFill>
+                  <a:srgbClr val="111110"/>
+                </a:solidFill>
+                <a:latin typeface="Instrument Sans"/>
+                <a:ea typeface="Instrument Sans"/>
+                <a:cs typeface="Instrument Sans"/>
+                <a:sym typeface="Instrument Sans"/>
+              </a:rPr>
+              <a:t>Apex Intelligence (超衍智能): </a:t>
+            </a:r>
+            <a:r>
+              <a:rPr lang="en-US" sz="850" b="0" i="0" u="none" strike="noStrike" cap="none">
+                <a:solidFill>
+                  <a:srgbClr val="33322F"/>
+                </a:solidFill>
+                <a:latin typeface="Instrument Sans"/>
+                <a:ea typeface="Instrument Sans"/>
+                <a:cs typeface="Instrument Sans"/>
+                <a:sym typeface="Instrument Sans"/>
+              </a:rPr>
+              <a:t>36Kr (Sep 16, 2026): self-improving (RSI) model company; angel and angel+ rounds of nearly RMB 400M, led by IDG Capital, Xinglian Capital and XtalPi</a:t>
             </a:r>
           </a:p>
         </p:txBody>
@@ -32172,7 +32517,7 @@
           <a:p>
             <a:pPr marL="0" marR="0" lvl="0" indent="0" algn="l" rtl="0">
               <a:lnSpc>
-                <a:spcPct val="110000"/>
+                <a:spcPct val="108000"/>
               </a:lnSpc>
               <a:spcBef>
                 <a:spcPts val="0"/>
@@ -32192,7 +32537,7 @@
                 <a:cs typeface="Instrument Sans"/>
                 <a:sym typeface="Instrument Sans"/>
               </a:rPr>
-              <a:t>Training data spend today: </a:t>
+              <a:t>Training-data vendor revenue: </a:t>
             </a:r>
             <a:r>
               <a:rPr lang="en-US" sz="850" b="0" i="0" u="none" strike="noStrike" cap="none">
@@ -32204,16 +32549,16 @@
                 <a:cs typeface="Instrument Sans"/>
                 <a:sym typeface="Instrument Sans"/>
               </a:rPr>
-              <a:t>Menlo Ventures (Jul 2026): 50+ vendors, ~$8.5B combined</a:t>
+              <a:t>Deedy Das, Menlo Ventures partner, AI training-data market map (Jul 2026): 50+ companies, ~$8.5B combined revenue (partly gross)</a:t>
             </a:r>
           </a:p>
           <a:p>
             <a:pPr marL="0" marR="0" lvl="0" indent="0" algn="l" rtl="0">
               <a:lnSpc>
-                <a:spcPct val="110000"/>
+                <a:spcPct val="108000"/>
               </a:lnSpc>
               <a:spcBef>
-                <a:spcPts val="500"/>
+                <a:spcPts val="300"/>
               </a:spcBef>
               <a:spcAft>
                 <a:spcPts val="0"/>
@@ -32242,16 +32587,16 @@
                 <a:cs typeface="Instrument Sans"/>
                 <a:sym typeface="Instrument Sans"/>
               </a:rPr>
-              <a:t>McKinsey, Agents, robots, and us (Nov 2025): US ~$2.9T; IMF WEO (Apr 2026): US GDP $32.4T, world $126.3T; half the US penetration assumed elsewhere</a:t>
+              <a:t>McKinsey, Agents, robots, and us (Nov 2025): US ~$2.9T of unlockable value; IMF WEO (Apr 2026): US GDP $32.4T, world $126.3T; half the US penetration assumed elsewhere</a:t>
             </a:r>
           </a:p>
           <a:p>
             <a:pPr marL="0" marR="0" lvl="0" indent="0" algn="l" rtl="0">
               <a:lnSpc>
-                <a:spcPct val="110000"/>
+                <a:spcPct val="108000"/>
               </a:lnSpc>
               <a:spcBef>
-                <a:spcPts val="500"/>
+                <a:spcPts val="300"/>
               </a:spcBef>
               <a:spcAft>
                 <a:spcPts val="0"/>
@@ -32286,10 +32631,10 @@
           <a:p>
             <a:pPr marL="0" marR="0" lvl="0" indent="0" algn="l" rtl="0">
               <a:lnSpc>
-                <a:spcPct val="110000"/>
+                <a:spcPct val="108000"/>
               </a:lnSpc>
               <a:spcBef>
-                <a:spcPts val="500"/>
+                <a:spcPts val="300"/>
               </a:spcBef>
               <a:spcAft>
                 <a:spcPts val="0"/>
@@ -32306,7 +32651,7 @@
                 <a:cs typeface="Instrument Sans"/>
                 <a:sym typeface="Instrument Sans"/>
               </a:rPr>
-              <a:t>AI agent market: </a:t>
+              <a:t>Agentic commerce: </a:t>
             </a:r>
             <a:r>
               <a:rPr lang="en-US" sz="850" b="0" i="0" u="none" strike="noStrike" cap="none">
@@ -32318,16 +32663,16 @@
                 <a:cs typeface="Instrument Sans"/>
                 <a:sym typeface="Instrument Sans"/>
               </a:rPr>
-              <a:t>Precedence Research ($7.92B in 2025; 45.82% CAGR); 2028 and 2032 extrapolated</a:t>
+              <a:t>McKinsey (Oct 2025): AI agents could handle $3–5T of global consumer commerce by 2030; cited by Ant International, Mastercard and Visa (CNBC, Sep 10, 2026)</a:t>
             </a:r>
           </a:p>
           <a:p>
             <a:pPr marL="0" marR="0" lvl="0" indent="0" algn="l" rtl="0">
               <a:lnSpc>
-                <a:spcPct val="110000"/>
+                <a:spcPct val="108000"/>
               </a:lnSpc>
               <a:spcBef>
-                <a:spcPts val="500"/>
+                <a:spcPts val="300"/>
               </a:spcBef>
               <a:spcAft>
                 <a:spcPts val="0"/>
@@ -32356,16 +32701,16 @@
                 <a:cs typeface="Instrument Sans"/>
                 <a:sym typeface="Instrument Sans"/>
               </a:rPr>
-              <a:t>Epoch AI, An FAQ on RL environments (Jan 2026)</a:t>
+              <a:t>Epoch AI, An FAQ on RL environments (2026)</a:t>
             </a:r>
           </a:p>
           <a:p>
             <a:pPr marL="0" marR="0" lvl="0" indent="0" algn="l" rtl="0">
               <a:lnSpc>
-                <a:spcPct val="110000"/>
+                <a:spcPct val="108000"/>
               </a:lnSpc>
               <a:spcBef>
-                <a:spcPts val="500"/>
+                <a:spcPts val="300"/>
               </a:spcBef>
               <a:spcAft>
                 <a:spcPts val="0"/>
@@ -32400,10 +32745,10 @@
           <a:p>
             <a:pPr marL="0" marR="0" lvl="0" indent="0" algn="l" rtl="0">
               <a:lnSpc>
-                <a:spcPct val="110000"/>
+                <a:spcPct val="108000"/>
               </a:lnSpc>
               <a:spcBef>
-                <a:spcPts val="500"/>
+                <a:spcPts val="300"/>
               </a:spcBef>
               <a:spcAft>
                 <a:spcPts val="0"/>
@@ -32432,16 +32777,16 @@
                 <a:cs typeface="Instrument Sans"/>
                 <a:sym typeface="Instrument Sans"/>
               </a:rPr>
-              <a:t>Applied Compute: Upstarts (Jun 2025, $20M seed at $100M post); The Information (Aug 2026, ~$3B in talks)</a:t>
+              <a:t>Applied Compute: Upstarts (Jun 2025, seed at $100M post); Forbes (Sep 1, 2026, raising $350M at $3.25B)</a:t>
             </a:r>
           </a:p>
           <a:p>
             <a:pPr marL="0" marR="0" lvl="0" indent="0" algn="l" rtl="0">
               <a:lnSpc>
-                <a:spcPct val="110000"/>
+                <a:spcPct val="108000"/>
               </a:lnSpc>
               <a:spcBef>
-                <a:spcPts val="500"/>
+                <a:spcPts val="300"/>
               </a:spcBef>
               <a:spcAft>
                 <a:spcPts val="0"/>
@@ -32470,16 +32815,16 @@
                 <a:cs typeface="Instrument Sans"/>
                 <a:sym typeface="Instrument Sans"/>
               </a:rPr>
-              <a:t>Meta Muse launch (Sep 8, 2026; Axios, CNBC); Bloomberg (Sep 21, 2026): Amazon blocks Muse; OpenAI unveils always-on Dots at DevDay (Sep 29, 2026; TechCrunch, CNBC)</a:t>
+              <a:t>Meta Muse (launched Sep 8, 2026; No. 1 on the US App Store Sep 18; TechCrunch, Business Insider); OpenAI Dots (DevDay, Sep 29, 2026; The Verge, CNBC); Qwen Personal Agent (Apsara, Sep 22, 2026); Manus Cue (Sep 28, 2026; Bloomberg)</a:t>
             </a:r>
           </a:p>
           <a:p>
             <a:pPr marL="0" marR="0" lvl="0" indent="0" algn="l" rtl="0">
               <a:lnSpc>
-                <a:spcPct val="110000"/>
+                <a:spcPct val="108000"/>
               </a:lnSpc>
               <a:spcBef>
-                <a:spcPts val="500"/>
+                <a:spcPts val="300"/>
               </a:spcBef>
               <a:spcAft>
                 <a:spcPts val="0"/>
@@ -32508,16 +32853,16 @@
                 <a:cs typeface="Instrument Sans"/>
                 <a:sym typeface="Instrument Sans"/>
               </a:rPr>
-              <a:t>Business Wire, Sep 28, 2026: $1B Series C at a $10B valuation from Sequoia, Benchmark and Coatue; valued at $2.5B 33 days earlier</a:t>
+              <a:t>Reuters and TechCrunch, Sep 28, 2026: $1B at a $10B valuation from Sequoia, Benchmark and Coatue; valued at $2.5B on Aug 26, 2026; founder Noah Shinn is 23</a:t>
             </a:r>
           </a:p>
           <a:p>
             <a:pPr marL="0" marR="0" lvl="0" indent="0" algn="l" rtl="0">
               <a:lnSpc>
-                <a:spcPct val="110000"/>
+                <a:spcPct val="108000"/>
               </a:lnSpc>
               <a:spcBef>
-                <a:spcPts val="500"/>
+                <a:spcPts val="300"/>
               </a:spcBef>
               <a:spcAft>
                 <a:spcPts val="0"/>
@@ -32547,6 +32892,44 @@
                 <a:sym typeface="Instrument Sans"/>
               </a:rPr>
               <a:t>Scale AI and CAIS, Jul 2026: the best model completes 16.1% of real freelance projects to a paying client’s standard</a:t>
+            </a:r>
+          </a:p>
+          <a:p>
+            <a:pPr marL="0" marR="0" lvl="0" indent="0" algn="l" rtl="0">
+              <a:lnSpc>
+                <a:spcPct val="108000"/>
+              </a:lnSpc>
+              <a:spcBef>
+                <a:spcPts val="300"/>
+              </a:spcBef>
+              <a:spcAft>
+                <a:spcPts val="0"/>
+              </a:spcAft>
+              <a:buNone/>
+            </a:pPr>
+            <a:r>
+              <a:rPr lang="en-US" sz="850" b="1" i="0" u="none" strike="noStrike" cap="none">
+                <a:solidFill>
+                  <a:srgbClr val="111110"/>
+                </a:solidFill>
+                <a:latin typeface="Instrument Sans"/>
+                <a:ea typeface="Instrument Sans"/>
+                <a:cs typeface="Instrument Sans"/>
+                <a:sym typeface="Instrument Sans"/>
+              </a:rPr>
+              <a:t>Event prediction: </a:t>
+            </a:r>
+            <a:r>
+              <a:rPr lang="en-US" sz="850" b="0" i="0" u="none" strike="noStrike" cap="none">
+                <a:solidFill>
+                  <a:srgbClr val="33322F"/>
+                </a:solidFill>
+                <a:latin typeface="Instrument Sans"/>
+                <a:ea typeface="Instrument Sans"/>
+                <a:cs typeface="Instrument Sans"/>
+                <a:sym typeface="Instrument Sans"/>
+              </a:rPr>
+              <a:t>PolyBench (arXiv 2604.14199, Apr 2026): 7 frontier models simulated trading on 38,666 Polymarket markets; only 2 made money</a:t>
             </a:r>
           </a:p>
         </p:txBody>
@@ -33530,7 +33913,7 @@
                 <a:cs typeface="Instrument Sans"/>
                 <a:sym typeface="Instrument Sans"/>
               </a:rPr>
-              <a:t>Recursive self-improvement: AI trains on its own results in real environments, stronger each round</a:t>
+              <a:t>Recursive self-improvement: AI helps build the next, better AI; we turn each round’s real outcomes into the next round’s training data</a:t>
             </a:r>
           </a:p>
         </p:txBody>
@@ -36409,7 +36792,7 @@
                 <a:cs typeface="Newsreader"/>
                 <a:sym typeface="Newsreader"/>
               </a:rPr>
-              <a:t>Mercor grew revenue 27x and valuation 10x within 18 months: </a:t>
+              <a:t>Mercor grew revenue 27x in 16 months and is in talks at $20B: </a:t>
             </a:r>
             <a:r>
               <a:rPr lang="en-US" sz="1600" b="0" i="0" u="none" strike="noStrike" cap="none">
@@ -36857,7 +37240,7 @@
                 <a:cs typeface="IBM Plex Mono"/>
                 <a:sym typeface="IBM Plex Mono"/>
               </a:rPr>
-              <a:t>Demand growth</a:t>
+              <a:t>Agents spending for people</a:t>
             </a:r>
           </a:p>
         </p:txBody>
@@ -36906,7 +37289,7 @@
                 <a:cs typeface="Newsreader"/>
                 <a:sym typeface="Newsreader"/>
               </a:rPr>
-              <a:t>14x</a:t>
+              <a:t>$3–5T</a:t>
             </a:r>
           </a:p>
         </p:txBody>
@@ -36958,7 +37341,7 @@
                 <a:cs typeface="Instrument Sans"/>
                 <a:sym typeface="Instrument Sans"/>
               </a:rPr>
-              <a:t>AI agent market forecast: $7.9B → ~$111B over 7 years</a:t>
+              <a:t>Global consumer commerce AI agents could handle by 2030 (McKinsey)</a:t>
             </a:r>
           </a:p>
         </p:txBody>
@@ -37417,7 +37800,7 @@
                 <a:cs typeface="Newsreader"/>
                 <a:sym typeface="Newsreader"/>
               </a:rPr>
-              <a:t>Nearly half</a:t>
+              <a:t>$1.5B+</a:t>
             </a:r>
           </a:p>
         </p:txBody>
@@ -37466,7 +37849,7 @@
                 <a:cs typeface="Instrument Sans"/>
                 <a:sym typeface="Instrument Sans"/>
               </a:rPr>
-              <a:t>of Scale AI’s new training projects use RL environments</a:t>
+              <a:t>Google’s reported deal with RL-environment startup Mechanize</a:t>
             </a:r>
           </a:p>
         </p:txBody>
@@ -37593,7 +37976,7 @@
                 <a:cs typeface="Instrument Sans"/>
                 <a:sym typeface="Instrument Sans"/>
               </a:rPr>
-              <a:t>AfterQuery valuation: $300M → $3.2B</a:t>
+              <a:t>AfterQuery valuation: $300M → $3.2B (reported)</a:t>
             </a:r>
           </a:p>
         </p:txBody>
@@ -37671,7 +38054,7 @@
                 <a:cs typeface="Newsreader"/>
                 <a:sym typeface="Newsreader"/>
               </a:rPr>
-              <a:t>Before 2032</a:t>
+              <a:t>2026–2032</a:t>
             </a:r>
           </a:p>
         </p:txBody>
@@ -37830,7 +38213,7 @@
                 <a:cs typeface="Instrument Sans"/>
                 <a:sym typeface="Instrument Sans"/>
               </a:rPr>
-              <a:t>Sources: Mercor (TechCrunch, Sacra, Dealroom, Bloomberg); AfterQuery (Business Wire, Forbes); Snorkel AI (company); Scale AI (Reuters, company blog); AI agents (Precedence Research); text stock (Epoch AI). See A2.</a:t>
+              <a:t>Sources: Mercor (TechCrunch, Sacra, Dealroom, Bloomberg, The Information); AfterQuery (Business Wire, Forbes); Snorkel AI (Reuters); Scale AI (Reuters); Mechanize (Business Insider); agentic commerce (McKinsey, via CNBC); text stock (Epoch AI). See A2.</a:t>
             </a:r>
           </a:p>
         </p:txBody>
@@ -39392,7 +39775,7 @@
                 <a:cs typeface="Newsreader"/>
                 <a:sym typeface="Newsreader"/>
               </a:rPr>
-              <a:t>Wrong once the result is in</a:t>
+              <a:t>Bets placed on it lose money</a:t>
             </a:r>
           </a:p>
         </p:txBody>
@@ -41020,7 +41403,7 @@
                 <a:cs typeface="Newsreader"/>
                 <a:sym typeface="Newsreader"/>
               </a:rPr>
-              <a:t>Autonomy and</a:t>
+              <a:t>Self-improvement</a:t>
             </a:r>
           </a:p>
           <a:p>
@@ -41046,7 +41429,7 @@
                 <a:cs typeface="Newsreader"/>
                 <a:sym typeface="Newsreader"/>
               </a:rPr>
-              <a:t>self-improvement</a:t>
+              <a:t>settled by real outcomes</a:t>
             </a:r>
           </a:p>
         </p:txBody>
@@ -41144,7 +41527,7 @@
                 <a:cs typeface="Newsreader"/>
                 <a:sym typeface="Newsreader"/>
               </a:rPr>
-              <a:t>Acing tests isn’t doing the job. AI’s next leap </a:t>
+              <a:t>A perfect test score doesn’t earn trust. AI’s next leap </a:t>
             </a:r>
             <a:r>
               <a:rPr lang="en-US" sz="2100" b="0" i="0" u="none" strike="noStrike" cap="none">
@@ -44307,7 +44690,7 @@
                 <a:cs typeface="Instrument Sans"/>
                 <a:sym typeface="Instrument Sans"/>
               </a:rPr>
-              <a:t>GPT 6</a:t>
+              <a:t>GPT-6</a:t>
             </a:r>
           </a:p>
         </p:txBody>

</xml_diff>

<commit_message>
BP v29: US-standard English deck, Chinese deck without terms, outreach email
- English deck in US dollars throughout: $6M seed at $75M post-money
  (8%), $3M per engine; US conventions for schools, honors and rounds
- Chinese external version (--no-terms): no round size, valuation,
  dilution or fund amounts; the round page is dropped and use of funds
  becomes the growth plan (22 pages)
- English email to overseas investors

Co-Authored-By: Claude Opus 5.5 <noreply@anthropic.com>
Claude-Session: https://claude.ai/code/session_01EKqGwTA92C8Wo4e47t73NN
</commit_message>
<xml_diff>
--- a/SimReal-BP-v29-EN.pptx
+++ b/SimReal-BP-v29-EN.pptx
@@ -6233,7 +6233,7 @@
                 <a:cs typeface="Instrument Sans"/>
                 <a:sym typeface="Instrument Sans"/>
               </a:rPr>
-              <a:t>RMB 40M (paid in USD)</a:t>
+              <a:t>$6M seed</a:t>
             </a:r>
           </a:p>
         </p:txBody>
@@ -18635,7 +18635,7 @@
                 <a:cs typeface="Instrument Sans"/>
                 <a:sym typeface="Instrument Sans"/>
               </a:rPr>
-              <a:t>Per Bloomberg, Alibaba is set to lead a $300M round in UniPat at a $2.5B valuation; Humanlaya closed a CDH-led Pre-A of several hundred million RMB;</a:t>
+              <a:t>Per Bloomberg, Alibaba is set to lead a $300M round in UniPat at a $2.5B valuation; Humanlaya closed a CDH-led pre-Series A reported at $30M+;</a:t>
             </a:r>
             <a:br>
               <a:rPr lang="en-US" sz="1000"/>
@@ -22035,7 +22035,7 @@
                 <a:cs typeface="Newsreader"/>
                 <a:sym typeface="Newsreader"/>
               </a:rPr>
-              <a:t>Raising RMB 40M </a:t>
+              <a:t>Raising $6M </a:t>
             </a:r>
             <a:r>
               <a:rPr lang="en-US" sz="1600" b="0" i="0" u="none" strike="noStrike" cap="none">
@@ -22047,7 +22047,7 @@
                 <a:cs typeface="Newsreader"/>
                 <a:sym typeface="Newsreader"/>
               </a:rPr>
-              <a:t>at RMB 500M post-money</a:t>
+              <a:t>at a $75M post-money valuation</a:t>
             </a:r>
           </a:p>
         </p:txBody>
@@ -22174,7 +22174,7 @@
                 <a:cs typeface="Newsreader"/>
                 <a:sym typeface="Newsreader"/>
               </a:rPr>
-              <a:t>RMB 40M</a:t>
+              <a:t>$6M</a:t>
             </a:r>
           </a:p>
         </p:txBody>
@@ -22223,7 +22223,7 @@
                 <a:cs typeface="Instrument Sans"/>
                 <a:sym typeface="Instrument Sans"/>
               </a:rPr>
-              <a:t>Paid in USD</a:t>
+              <a:t>Seed round</a:t>
             </a:r>
           </a:p>
         </p:txBody>
@@ -22477,7 +22477,7 @@
                 <a:cs typeface="Newsreader"/>
                 <a:sym typeface="Newsreader"/>
               </a:rPr>
-              <a:t>RMB 460M</a:t>
+              <a:t>$69M</a:t>
             </a:r>
           </a:p>
         </p:txBody>
@@ -22604,7 +22604,7 @@
                 <a:cs typeface="Newsreader"/>
                 <a:sym typeface="Newsreader"/>
               </a:rPr>
-              <a:t>RMB 500M</a:t>
+              <a:t>$75M</a:t>
             </a:r>
           </a:p>
         </p:txBody>
@@ -23069,7 +23069,7 @@
                 <a:cs typeface="Newsreader"/>
                 <a:sym typeface="Newsreader"/>
               </a:rPr>
-              <a:t>~RMB 400M</a:t>
+              <a:t>~$60M</a:t>
             </a:r>
           </a:p>
         </p:txBody>
@@ -23675,7 +23675,7 @@
                 <a:cs typeface="Newsreader"/>
                 <a:sym typeface="Newsreader"/>
               </a:rPr>
-              <a:t>HSG, CDH, Capital Today, BAI and IDG are in; Alibaba and Tencent are moving in: </a:t>
+              <a:t>In China, HSG, CDH, Capital Today, BAI and IDG are in; Alibaba and Tencent are moving in: </a:t>
             </a:r>
             <a:r>
               <a:rPr lang="en-US" sz="1600" b="0" i="0" u="none" strike="noStrike" cap="none">
@@ -24312,7 +24312,7 @@
                 <a:cs typeface="IBM Plex Mono"/>
                 <a:sym typeface="IBM Plex Mono"/>
               </a:rPr>
-              <a:t>01  Revenue engine  ·  RMB 20M</a:t>
+              <a:t>01  Revenue engine  ·  $3M</a:t>
             </a:r>
           </a:p>
         </p:txBody>
@@ -24488,7 +24488,7 @@
                 <a:cs typeface="Newsreader"/>
                 <a:sym typeface="Newsreader"/>
               </a:rPr>
-              <a:t>RMB 7M</a:t>
+              <a:t>$1.05M</a:t>
             </a:r>
           </a:p>
         </p:txBody>
@@ -24664,7 +24664,7 @@
                 <a:cs typeface="Newsreader"/>
                 <a:sym typeface="Newsreader"/>
               </a:rPr>
-              <a:t>RMB 4M</a:t>
+              <a:t>$600K</a:t>
             </a:r>
           </a:p>
         </p:txBody>
@@ -24840,7 +24840,7 @@
                 <a:cs typeface="Newsreader"/>
                 <a:sym typeface="Newsreader"/>
               </a:rPr>
-              <a:t>RMB 6M</a:t>
+              <a:t>$900K</a:t>
             </a:r>
           </a:p>
         </p:txBody>
@@ -25016,7 +25016,7 @@
                 <a:cs typeface="Newsreader"/>
                 <a:sym typeface="Newsreader"/>
               </a:rPr>
-              <a:t>RMB 3M</a:t>
+              <a:t>$450K</a:t>
             </a:r>
           </a:p>
         </p:txBody>
@@ -25688,7 +25688,7 @@
                 <a:cs typeface="IBM Plex Mono"/>
                 <a:sym typeface="IBM Plex Mono"/>
               </a:rPr>
-              <a:t>02  RSI engine  ·  RMB 20M</a:t>
+              <a:t>02  RSI engine  ·  $3M</a:t>
             </a:r>
           </a:p>
         </p:txBody>
@@ -25864,7 +25864,7 @@
                 <a:cs typeface="Newsreader"/>
                 <a:sym typeface="Newsreader"/>
               </a:rPr>
-              <a:t>RMB 9M</a:t>
+              <a:t>$1.35M</a:t>
             </a:r>
           </a:p>
         </p:txBody>
@@ -26040,7 +26040,7 @@
                 <a:cs typeface="Newsreader"/>
                 <a:sym typeface="Newsreader"/>
               </a:rPr>
-              <a:t>RMB 7M</a:t>
+              <a:t>$1.05M</a:t>
             </a:r>
           </a:p>
         </p:txBody>
@@ -26216,7 +26216,7 @@
                 <a:cs typeface="Newsreader"/>
                 <a:sym typeface="Newsreader"/>
               </a:rPr>
-              <a:t>RMB 4M</a:t>
+              <a:t>$600K</a:t>
             </a:r>
           </a:p>
         </p:txBody>
@@ -28919,7 +28919,7 @@
                 <a:cs typeface="Newsreader"/>
                 <a:sym typeface="Newsreader"/>
               </a:rPr>
-              <a:t>RMB 40M</a:t>
+              <a:t>$6M</a:t>
             </a:r>
           </a:p>
         </p:txBody>
@@ -28971,7 +28971,7 @@
                 <a:cs typeface="Instrument Sans"/>
                 <a:sym typeface="Instrument Sans"/>
               </a:rPr>
-              <a:t>Paid in USD; RMB 500M post-money</a:t>
+              <a:t>At a $75M post-money valuation</a:t>
             </a:r>
           </a:p>
           <a:p>
@@ -28997,7 +28997,7 @@
                 <a:cs typeface="Instrument Sans"/>
                 <a:sym typeface="Instrument Sans"/>
               </a:rPr>
-              <a:t>RMB 20M each for the revenue and RSI engines</a:t>
+              <a:t>$3M each for the revenue and RSI engines</a:t>
             </a:r>
           </a:p>
         </p:txBody>
@@ -32369,7 +32369,7 @@
                 <a:cs typeface="Instrument Sans"/>
                 <a:sym typeface="Instrument Sans"/>
               </a:rPr>
-              <a:t>Founded 2025; Pre-A of several hundred million RMB in Sep 2026, led by CDH with HSG, Capital Today and BAI (Jiemian, Eastmoney)</a:t>
+              <a:t>Founded 2025; pre-Series A reported at several hundred million RMB ($30M+) in Sep 2026, led by CDH with HSG, Capital Today and BAI (Jiemian, Eastmoney)</a:t>
             </a:r>
           </a:p>
           <a:p>
@@ -32407,7 +32407,7 @@
                 <a:cs typeface="Instrument Sans"/>
                 <a:sym typeface="Instrument Sans"/>
               </a:rPr>
-              <a:t>36Kr (Sep 16, 2026): self-improving (RSI) model company; angel and angel+ rounds of nearly RMB 400M, led by IDG Capital, Xinglian Capital and XtalPi</a:t>
+              <a:t>36Kr (Sep 16, 2026): self-improving (RSI) model company; angel and angel+ rounds of nearly RMB 400M (~$60M), led by IDG Capital, Xinglian Capital and XtalPi</a:t>
             </a:r>
           </a:p>
         </p:txBody>
@@ -35577,7 +35577,7 @@
                 <a:cs typeface="Instrument Sans"/>
                 <a:sym typeface="Instrument Sans"/>
               </a:rPr>
-              <a:t>Born 2005 · LSE Mathematics · SCIE</a:t>
+              <a:t>Born 2005 · LSE, Math · SCIE (Shenzhen)</a:t>
             </a:r>
           </a:p>
           <a:p>
@@ -35904,7 +35904,7 @@
                 <a:cs typeface="Instrument Sans"/>
                 <a:sym typeface="Instrument Sans"/>
               </a:rPr>
-              <a:t>Born 2005 · Cambridge Math, First (Scholar) · SCIE</a:t>
+              <a:t>Born 2005 · Cambridge Math, First-Class (Scholar)</a:t>
             </a:r>
           </a:p>
           <a:p>
@@ -35956,7 +35956,7 @@
                 <a:cs typeface="Instrument Sans"/>
                 <a:sym typeface="Instrument Sans"/>
               </a:rPr>
-              <a:t>UK Physics Olympiad Super Gold</a:t>
+              <a:t>UK Physics Olympiad Super Gold · SCIE (Shenzhen)</a:t>
             </a:r>
           </a:p>
         </p:txBody>
@@ -36257,7 +36257,33 @@
                 <a:cs typeface="Instrument Sans"/>
                 <a:sym typeface="Instrument Sans"/>
               </a:rPr>
-              <a:t>Born 2005 · Duke Math &amp; Statistics · YK Pao School</a:t>
+              <a:t>Born 2005 · Duke, Math &amp; Statistics</a:t>
+            </a:r>
+          </a:p>
+          <a:p>
+            <a:pPr marL="0" marR="0" lvl="0" indent="0" algn="l" rtl="0">
+              <a:lnSpc>
+                <a:spcPct val="112000"/>
+              </a:lnSpc>
+              <a:spcBef>
+                <a:spcPts val="0"/>
+              </a:spcBef>
+              <a:spcAft>
+                <a:spcPts val="0"/>
+              </a:spcAft>
+              <a:buNone/>
+            </a:pPr>
+            <a:r>
+              <a:rPr lang="en-US" sz="900" b="0" i="0" u="none" strike="noStrike" cap="none">
+                <a:solidFill>
+                  <a:srgbClr val="6E6C66"/>
+                </a:solidFill>
+                <a:latin typeface="Instrument Sans"/>
+                <a:ea typeface="Instrument Sans"/>
+                <a:cs typeface="Instrument Sans"/>
+                <a:sym typeface="Instrument Sans"/>
+              </a:rPr>
+              <a:t>YK Pao School (Shanghai)</a:t>
             </a:r>
           </a:p>
         </p:txBody>

</xml_diff>